<commit_message>
Update finance slide cost structure: ads 40%, goods 30%, team ops 8%, ~22% operating profit
Co-authored-by: devlee <devlee@outlook.com>
</commit_message>
<xml_diff>
--- a/ppt/克拉先生_裂变项目总经理竞选PPT.pptx
+++ b/ppt/克拉先生_裂变项目总经理竞选PPT.pptx
@@ -17894,7 +17894,7 @@
                 <a:latin typeface="Noto Sans CJK SC"/>
                 <a:ea typeface="Noto Sans CJK SC"/>
               </a:rPr>
-              <a:t>广告及营销投放</a:t>
+              <a:t>广告及营销投放（40%）</a:t>
             </a:r>
           </a:p>
         </p:txBody>
@@ -17983,7 +17983,7 @@
                 <a:latin typeface="Noto Sans CJK SC"/>
                 <a:ea typeface="Noto Sans CJK SC"/>
               </a:rPr>
-              <a:t>150</a:t>
+              <a:t>200</a:t>
             </a:r>
           </a:p>
         </p:txBody>
@@ -18072,7 +18072,7 @@
                 <a:latin typeface="Noto Sans CJK SC"/>
                 <a:ea typeface="Noto Sans CJK SC"/>
               </a:rPr>
-              <a:t>380</a:t>
+              <a:t>600</a:t>
             </a:r>
           </a:p>
         </p:txBody>
@@ -18161,7 +18161,7 @@
                 <a:latin typeface="Noto Sans CJK SC"/>
                 <a:ea typeface="Noto Sans CJK SC"/>
               </a:rPr>
-              <a:t>820</a:t>
+              <a:t>1,440</a:t>
             </a:r>
           </a:p>
         </p:txBody>
@@ -18250,7 +18250,7 @@
                 <a:latin typeface="Noto Sans CJK SC"/>
                 <a:ea typeface="Noto Sans CJK SC"/>
               </a:rPr>
-              <a:t>货品及履约成本</a:t>
+              <a:t>货品及履约成本（30%）</a:t>
             </a:r>
           </a:p>
         </p:txBody>
@@ -18339,7 +18339,7 @@
                 <a:latin typeface="Noto Sans CJK SC"/>
                 <a:ea typeface="Noto Sans CJK SC"/>
               </a:rPr>
-              <a:t>290</a:t>
+              <a:t>150</a:t>
             </a:r>
           </a:p>
         </p:txBody>
@@ -18428,7 +18428,7 @@
                 <a:latin typeface="Noto Sans CJK SC"/>
                 <a:ea typeface="Noto Sans CJK SC"/>
               </a:rPr>
-              <a:t>830</a:t>
+              <a:t>450</a:t>
             </a:r>
           </a:p>
         </p:txBody>
@@ -18517,7 +18517,7 @@
                 <a:latin typeface="Noto Sans CJK SC"/>
                 <a:ea typeface="Noto Sans CJK SC"/>
               </a:rPr>
-              <a:t>1,950</a:t>
+              <a:t>1,080</a:t>
             </a:r>
           </a:p>
         </p:txBody>
@@ -18606,7 +18606,7 @@
                 <a:latin typeface="Noto Sans CJK SC"/>
                 <a:ea typeface="Noto Sans CJK SC"/>
               </a:rPr>
-              <a:t>团队及运营费用</a:t>
+              <a:t>团队及运营费用（8%）</a:t>
             </a:r>
           </a:p>
         </p:txBody>
@@ -18695,7 +18695,7 @@
                 <a:latin typeface="Noto Sans CJK SC"/>
                 <a:ea typeface="Noto Sans CJK SC"/>
               </a:rPr>
-              <a:t>85</a:t>
+              <a:t>40</a:t>
             </a:r>
           </a:p>
         </p:txBody>
@@ -18784,7 +18784,7 @@
                 <a:latin typeface="Noto Sans CJK SC"/>
                 <a:ea typeface="Noto Sans CJK SC"/>
               </a:rPr>
-              <a:t>150</a:t>
+              <a:t>120</a:t>
             </a:r>
           </a:p>
         </p:txBody>
@@ -18873,7 +18873,7 @@
                 <a:latin typeface="Noto Sans CJK SC"/>
                 <a:ea typeface="Noto Sans CJK SC"/>
               </a:rPr>
-              <a:t>250</a:t>
+              <a:t>288</a:t>
             </a:r>
           </a:p>
         </p:txBody>
@@ -18962,7 +18962,7 @@
                 <a:latin typeface="Noto Sans CJK SC"/>
                 <a:ea typeface="Noto Sans CJK SC"/>
               </a:rPr>
-              <a:t>净利润</a:t>
+              <a:t>经营利润（约 22%）</a:t>
             </a:r>
           </a:p>
         </p:txBody>
@@ -19051,7 +19051,7 @@
                 <a:latin typeface="Noto Sans CJK SC"/>
                 <a:ea typeface="Noto Sans CJK SC"/>
               </a:rPr>
-              <a:t>▲ -25（战略亏损）</a:t>
+              <a:t>110</a:t>
             </a:r>
           </a:p>
         </p:txBody>
@@ -19140,7 +19140,7 @@
                 <a:latin typeface="Noto Sans CJK SC"/>
                 <a:ea typeface="Noto Sans CJK SC"/>
               </a:rPr>
-              <a:t>140（利润率 9%）</a:t>
+              <a:t>330</a:t>
             </a:r>
           </a:p>
         </p:txBody>
@@ -19229,7 +19229,7 @@
                 <a:latin typeface="Noto Sans CJK SC"/>
                 <a:ea typeface="Noto Sans CJK SC"/>
               </a:rPr>
-              <a:t>580（利润率 16%）</a:t>
+              <a:t>792</a:t>
             </a:r>
           </a:p>
         </p:txBody>
@@ -19316,7 +19316,7 @@
                 <a:latin typeface="Noto Sans CJK SC"/>
                 <a:ea typeface="Noto Sans CJK SC"/>
               </a:rPr>
-              <a:t>零库存模型：</a:t>
+              <a:t>成本结构：</a:t>
             </a:r>
             <a:r>
               <a:rPr sz="1300" b="0" i="0">
@@ -19326,7 +19326,7 @@
                 <a:latin typeface="Noto Sans CJK SC"/>
                 <a:ea typeface="Noto Sans CJK SC"/>
               </a:rPr>
-              <a:t>一件一做，货品成本随订单发生，160 万主要投向流量与团队，资金效率高</a:t>
+              <a:t>广告 40% + 货品 30% + 团队运营 8%，经营利润率约 22%；扣除支付手续费、物流保险等杂费后净利率 15%~20%</a:t>
             </a:r>
           </a:p>
         </p:txBody>
@@ -19413,7 +19413,7 @@
                 <a:latin typeface="Noto Sans CJK SC"/>
                 <a:ea typeface="Noto Sans CJK SC"/>
               </a:rPr>
-              <a:t>利润率锚点：</a:t>
+              <a:t>零库存模型：</a:t>
             </a:r>
             <a:r>
               <a:rPr sz="1300" b="0" i="0">
@@ -19423,7 +19423,7 @@
                 <a:latin typeface="Noto Sans CJK SC"/>
                 <a:ea typeface="Noto Sans CJK SC"/>
               </a:rPr>
-              <a:t>第 3 年稳态利润率 15%~20%，利润来自设计与定制服务溢价，而非裸钻差价</a:t>
+              <a:t>一件一做，货品成本随订单发生，160 万主要投向流量与团队，资金效率高</a:t>
             </a:r>
           </a:p>
         </p:txBody>
@@ -19520,7 +19520,7 @@
                 <a:latin typeface="Noto Sans CJK SC"/>
                 <a:ea typeface="Noto Sans CJK SC"/>
               </a:rPr>
-              <a:t>跑通单站模型后复制放大，3~5 年冲击年营收 5,000 万美金量级</a:t>
+              <a:t>利润来自设计与定制服务溢价；跑通单站模型后复制放大，3~5 年冲击年营收 5,000 万美金量级</a:t>
             </a:r>
           </a:p>
         </p:txBody>

</xml_diff>

<commit_message>
Embed rings comparison photo into opening hook slide with A/B suspense labels
Co-authored-by: devlee <devlee@outlook.com>
</commit_message>
<xml_diff>
--- a/ppt/克拉先生_裂变项目总经理竞选PPT.pptx
+++ b/ppt/克拉先生_裂变项目总经理竞选PPT.pptx
@@ -7319,18 +7319,974 @@
       </p:sp>
       <p:sp>
         <p:nvSpPr>
-          <p:cNvPr id="6" name="Rounded Rectangle 5"/>
+          <p:cNvPr id="6" name="Rectangle 5"/>
           <p:cNvSpPr/>
           <p:nvPr/>
         </p:nvSpPr>
         <p:spPr>
           <a:xfrm>
-            <a:off x="868680" y="1783080"/>
-            <a:ext cx="2560320" cy="1920240"/>
+            <a:off x="830580" y="1653540"/>
+            <a:ext cx="3733800" cy="3733800"/>
+          </a:xfrm>
+          <a:prstGeom prst="rect">
+            <a:avLst/>
+          </a:prstGeom>
+          <a:solidFill>
+            <a:srgbClr val="C9A24B"/>
+          </a:solidFill>
+          <a:ln>
+            <a:noFill/>
+          </a:ln>
+          <a:effectLst/>
+        </p:spPr>
+        <p:style>
+          <a:lnRef idx="1">
+            <a:schemeClr val="accent1"/>
+          </a:lnRef>
+          <a:fillRef idx="3">
+            <a:schemeClr val="accent1"/>
+          </a:fillRef>
+          <a:effectRef idx="2">
+            <a:schemeClr val="accent1"/>
+          </a:effectRef>
+          <a:fontRef idx="minor">
+            <a:schemeClr val="lt1"/>
+          </a:fontRef>
+        </p:style>
+        <p:txBody>
+          <a:bodyPr rtlCol="0" anchor="ctr"/>
+          <a:lstStyle/>
+          <a:p>
+            <a:pPr algn="ctr"/>
+          </a:p>
+        </p:txBody>
+      </p:sp>
+      <p:pic>
+        <p:nvPicPr>
+          <p:cNvPr id="7" name="Picture 6" descr="rings_comparison.png"/>
+          <p:cNvPicPr>
+            <a:picLocks noChangeAspect="1"/>
+          </p:cNvPicPr>
+          <p:nvPr/>
+        </p:nvPicPr>
+        <p:blipFill>
+          <a:blip r:embed="rId2"/>
+          <a:stretch>
+            <a:fillRect/>
+          </a:stretch>
+        </p:blipFill>
+        <p:spPr>
+          <a:xfrm>
+            <a:off x="868680" y="1691640"/>
+            <a:ext cx="3657600" cy="3657600"/>
+          </a:xfrm>
+          <a:prstGeom prst="rect">
+            <a:avLst/>
+          </a:prstGeom>
+        </p:spPr>
+      </p:pic>
+      <p:sp>
+        <p:nvSpPr>
+          <p:cNvPr id="8" name="Rounded Rectangle 7"/>
+          <p:cNvSpPr/>
+          <p:nvPr/>
+        </p:nvSpPr>
+        <p:spPr>
+          <a:xfrm>
+            <a:off x="1371600" y="4846320"/>
+            <a:ext cx="502920" cy="365760"/>
           </a:xfrm>
           <a:prstGeom prst="roundRect">
             <a:avLst>
-              <a:gd name="adj" fmla="val 8000"/>
+              <a:gd name="adj" fmla="val 50000"/>
+            </a:avLst>
+          </a:prstGeom>
+          <a:solidFill>
+            <a:srgbClr val="112A46"/>
+          </a:solidFill>
+          <a:ln w="12700">
+            <a:solidFill>
+              <a:srgbClr val="C9A24B"/>
+            </a:solidFill>
+          </a:ln>
+          <a:effectLst/>
+        </p:spPr>
+        <p:style>
+          <a:lnRef idx="1">
+            <a:schemeClr val="accent1"/>
+          </a:lnRef>
+          <a:fillRef idx="3">
+            <a:schemeClr val="accent1"/>
+          </a:fillRef>
+          <a:effectRef idx="2">
+            <a:schemeClr val="accent1"/>
+          </a:effectRef>
+          <a:fontRef idx="minor">
+            <a:schemeClr val="lt1"/>
+          </a:fontRef>
+        </p:style>
+        <p:txBody>
+          <a:bodyPr rtlCol="0" anchor="ctr"/>
+          <a:lstStyle/>
+          <a:p>
+            <a:pPr algn="ctr"/>
+          </a:p>
+        </p:txBody>
+      </p:sp>
+      <p:sp>
+        <p:nvSpPr>
+          <p:cNvPr id="9" name="TextBox 8"/>
+          <p:cNvSpPr txBox="1"/>
+          <p:nvPr/>
+        </p:nvSpPr>
+        <p:spPr>
+          <a:xfrm>
+            <a:off x="1371600" y="4846320"/>
+            <a:ext cx="502920" cy="365760"/>
+          </a:xfrm>
+          <a:prstGeom prst="rect">
+            <a:avLst/>
+          </a:prstGeom>
+          <a:noFill/>
+        </p:spPr>
+        <p:txBody>
+          <a:bodyPr wrap="square" anchor="ctr" lIns="0" rIns="0" tIns="0" bIns="0">
+            <a:spAutoFit/>
+          </a:bodyPr>
+          <a:lstStyle/>
+          <a:p>
+            <a:pPr algn="ctr">
+              <a:lnSpc>
+                <a:spcPct val="100000"/>
+              </a:lnSpc>
+              <a:spcAft>
+                <a:spcPts val="0"/>
+              </a:spcAft>
+            </a:pPr>
+            <a:r>
+              <a:rPr sz="1400" b="1" i="0">
+                <a:solidFill>
+                  <a:srgbClr val="C9A24B"/>
+                </a:solidFill>
+                <a:latin typeface="Noto Sans CJK SC"/>
+                <a:ea typeface="Noto Sans CJK SC"/>
+              </a:rPr>
+              <a:t>A</a:t>
+            </a:r>
+          </a:p>
+        </p:txBody>
+      </p:sp>
+      <p:sp>
+        <p:nvSpPr>
+          <p:cNvPr id="10" name="Rounded Rectangle 9"/>
+          <p:cNvSpPr/>
+          <p:nvPr/>
+        </p:nvSpPr>
+        <p:spPr>
+          <a:xfrm>
+            <a:off x="3520440" y="4846320"/>
+            <a:ext cx="502920" cy="365760"/>
+          </a:xfrm>
+          <a:prstGeom prst="roundRect">
+            <a:avLst>
+              <a:gd name="adj" fmla="val 50000"/>
+            </a:avLst>
+          </a:prstGeom>
+          <a:solidFill>
+            <a:srgbClr val="112A46"/>
+          </a:solidFill>
+          <a:ln w="12700">
+            <a:solidFill>
+              <a:srgbClr val="C9A24B"/>
+            </a:solidFill>
+          </a:ln>
+          <a:effectLst/>
+        </p:spPr>
+        <p:style>
+          <a:lnRef idx="1">
+            <a:schemeClr val="accent1"/>
+          </a:lnRef>
+          <a:fillRef idx="3">
+            <a:schemeClr val="accent1"/>
+          </a:fillRef>
+          <a:effectRef idx="2">
+            <a:schemeClr val="accent1"/>
+          </a:effectRef>
+          <a:fontRef idx="minor">
+            <a:schemeClr val="lt1"/>
+          </a:fontRef>
+        </p:style>
+        <p:txBody>
+          <a:bodyPr rtlCol="0" anchor="ctr"/>
+          <a:lstStyle/>
+          <a:p>
+            <a:pPr algn="ctr"/>
+          </a:p>
+        </p:txBody>
+      </p:sp>
+      <p:sp>
+        <p:nvSpPr>
+          <p:cNvPr id="11" name="TextBox 10"/>
+          <p:cNvSpPr txBox="1"/>
+          <p:nvPr/>
+        </p:nvSpPr>
+        <p:spPr>
+          <a:xfrm>
+            <a:off x="3520440" y="4846320"/>
+            <a:ext cx="502920" cy="365760"/>
+          </a:xfrm>
+          <a:prstGeom prst="rect">
+            <a:avLst/>
+          </a:prstGeom>
+          <a:noFill/>
+        </p:spPr>
+        <p:txBody>
+          <a:bodyPr wrap="square" anchor="ctr" lIns="0" rIns="0" tIns="0" bIns="0">
+            <a:spAutoFit/>
+          </a:bodyPr>
+          <a:lstStyle/>
+          <a:p>
+            <a:pPr algn="ctr">
+              <a:lnSpc>
+                <a:spcPct val="100000"/>
+              </a:lnSpc>
+              <a:spcAft>
+                <a:spcPts val="0"/>
+              </a:spcAft>
+            </a:pPr>
+            <a:r>
+              <a:rPr sz="1400" b="1" i="0">
+                <a:solidFill>
+                  <a:srgbClr val="C9A24B"/>
+                </a:solidFill>
+                <a:latin typeface="Noto Sans CJK SC"/>
+                <a:ea typeface="Noto Sans CJK SC"/>
+              </a:rPr>
+              <a:t>B</a:t>
+            </a:r>
+          </a:p>
+        </p:txBody>
+      </p:sp>
+      <p:sp>
+        <p:nvSpPr>
+          <p:cNvPr id="12" name="TextBox 11"/>
+          <p:cNvSpPr txBox="1"/>
+          <p:nvPr/>
+        </p:nvSpPr>
+        <p:spPr>
+          <a:xfrm>
+            <a:off x="868680" y="5440680"/>
+            <a:ext cx="3657600" cy="365760"/>
+          </a:xfrm>
+          <a:prstGeom prst="rect">
+            <a:avLst/>
+          </a:prstGeom>
+          <a:noFill/>
+        </p:spPr>
+        <p:txBody>
+          <a:bodyPr wrap="square" anchor="t" lIns="0" rIns="0" tIns="0" bIns="0">
+            <a:spAutoFit/>
+          </a:bodyPr>
+          <a:lstStyle/>
+          <a:p>
+            <a:pPr algn="ctr">
+              <a:lnSpc>
+                <a:spcPct val="100000"/>
+              </a:lnSpc>
+              <a:spcAft>
+                <a:spcPts val="0"/>
+              </a:spcAft>
+            </a:pPr>
+            <a:r>
+              <a:rPr sz="1400" b="1" i="0">
+                <a:solidFill>
+                  <a:srgbClr val="E8D5A3"/>
+                </a:solidFill>
+                <a:latin typeface="Noto Sans CJK SC"/>
+                <a:ea typeface="Noto Sans CJK SC"/>
+              </a:rPr>
+              <a:t>其中一颗是培育钻 —— 您能分辨吗？</a:t>
+            </a:r>
+          </a:p>
+        </p:txBody>
+      </p:sp>
+      <p:sp>
+        <p:nvSpPr>
+          <p:cNvPr id="13" name="Rounded Rectangle 12"/>
+          <p:cNvSpPr/>
+          <p:nvPr/>
+        </p:nvSpPr>
+        <p:spPr>
+          <a:xfrm>
+            <a:off x="5029200" y="1691640"/>
+            <a:ext cx="6583680" cy="566928"/>
+          </a:xfrm>
+          <a:prstGeom prst="roundRect">
+            <a:avLst>
+              <a:gd name="adj" fmla="val 18000"/>
+            </a:avLst>
+          </a:prstGeom>
+          <a:solidFill>
+            <a:srgbClr val="1E3D5C"/>
+          </a:solidFill>
+          <a:ln>
+            <a:noFill/>
+          </a:ln>
+          <a:effectLst/>
+        </p:spPr>
+        <p:style>
+          <a:lnRef idx="1">
+            <a:schemeClr val="accent1"/>
+          </a:lnRef>
+          <a:fillRef idx="3">
+            <a:schemeClr val="accent1"/>
+          </a:fillRef>
+          <a:effectRef idx="2">
+            <a:schemeClr val="accent1"/>
+          </a:effectRef>
+          <a:fontRef idx="minor">
+            <a:schemeClr val="lt1"/>
+          </a:fontRef>
+        </p:style>
+        <p:txBody>
+          <a:bodyPr rtlCol="0" anchor="ctr"/>
+          <a:lstStyle/>
+          <a:p>
+            <a:pPr algn="ctr"/>
+          </a:p>
+        </p:txBody>
+      </p:sp>
+      <p:sp>
+        <p:nvSpPr>
+          <p:cNvPr id="14" name="Rounded Rectangle 13"/>
+          <p:cNvSpPr/>
+          <p:nvPr/>
+        </p:nvSpPr>
+        <p:spPr>
+          <a:xfrm>
+            <a:off x="5029200" y="1691640"/>
+            <a:ext cx="1234440" cy="566928"/>
+          </a:xfrm>
+          <a:prstGeom prst="roundRect">
+            <a:avLst>
+              <a:gd name="adj" fmla="val 18000"/>
+            </a:avLst>
+          </a:prstGeom>
+          <a:solidFill>
+            <a:srgbClr val="2E7D52"/>
+          </a:solidFill>
+          <a:ln>
+            <a:noFill/>
+          </a:ln>
+          <a:effectLst/>
+        </p:spPr>
+        <p:style>
+          <a:lnRef idx="1">
+            <a:schemeClr val="accent1"/>
+          </a:lnRef>
+          <a:fillRef idx="3">
+            <a:schemeClr val="accent1"/>
+          </a:fillRef>
+          <a:effectRef idx="2">
+            <a:schemeClr val="accent1"/>
+          </a:effectRef>
+          <a:fontRef idx="minor">
+            <a:schemeClr val="lt1"/>
+          </a:fontRef>
+        </p:style>
+        <p:txBody>
+          <a:bodyPr rtlCol="0" anchor="ctr"/>
+          <a:lstStyle/>
+          <a:p>
+            <a:pPr algn="ctr"/>
+          </a:p>
+        </p:txBody>
+      </p:sp>
+      <p:sp>
+        <p:nvSpPr>
+          <p:cNvPr id="15" name="TextBox 14"/>
+          <p:cNvSpPr txBox="1"/>
+          <p:nvPr/>
+        </p:nvSpPr>
+        <p:spPr>
+          <a:xfrm>
+            <a:off x="5093208" y="1691640"/>
+            <a:ext cx="1115568" cy="566928"/>
+          </a:xfrm>
+          <a:prstGeom prst="rect">
+            <a:avLst/>
+          </a:prstGeom>
+          <a:noFill/>
+        </p:spPr>
+        <p:txBody>
+          <a:bodyPr wrap="square" anchor="ctr" lIns="0" rIns="0" tIns="0" bIns="0">
+            <a:spAutoFit/>
+          </a:bodyPr>
+          <a:lstStyle/>
+          <a:p>
+            <a:pPr algn="ctr">
+              <a:lnSpc>
+                <a:spcPct val="100000"/>
+              </a:lnSpc>
+              <a:spcAft>
+                <a:spcPts val="600"/>
+              </a:spcAft>
+            </a:pPr>
+            <a:r>
+              <a:rPr sz="1350" b="1" i="0">
+                <a:solidFill>
+                  <a:srgbClr val="FFFFFF"/>
+                </a:solidFill>
+                <a:latin typeface="Noto Sans CJK SC"/>
+                <a:ea typeface="Noto Sans CJK SC"/>
+              </a:rPr>
+              <a:t>相同</a:t>
+            </a:r>
+          </a:p>
+        </p:txBody>
+      </p:sp>
+      <p:sp>
+        <p:nvSpPr>
+          <p:cNvPr id="16" name="TextBox 15"/>
+          <p:cNvSpPr txBox="1"/>
+          <p:nvPr/>
+        </p:nvSpPr>
+        <p:spPr>
+          <a:xfrm>
+            <a:off x="6400800" y="1691640"/>
+            <a:ext cx="5120640" cy="566928"/>
+          </a:xfrm>
+          <a:prstGeom prst="rect">
+            <a:avLst/>
+          </a:prstGeom>
+          <a:noFill/>
+        </p:spPr>
+        <p:txBody>
+          <a:bodyPr wrap="square" anchor="ctr" lIns="0" rIns="0" tIns="0" bIns="0">
+            <a:spAutoFit/>
+          </a:bodyPr>
+          <a:lstStyle/>
+          <a:p>
+            <a:pPr algn="l">
+              <a:lnSpc>
+                <a:spcPct val="100000"/>
+              </a:lnSpc>
+              <a:spcAft>
+                <a:spcPts val="0"/>
+              </a:spcAft>
+            </a:pPr>
+            <a:r>
+              <a:rPr sz="1450" b="1" i="0">
+                <a:solidFill>
+                  <a:srgbClr val="FFFFFF"/>
+                </a:solidFill>
+                <a:latin typeface="Noto Sans CJK SC"/>
+                <a:ea typeface="Noto Sans CJK SC"/>
+              </a:rPr>
+              <a:t>视觉 · 化学结构 · 硬度</a:t>
+            </a:r>
+          </a:p>
+        </p:txBody>
+      </p:sp>
+      <p:sp>
+        <p:nvSpPr>
+          <p:cNvPr id="17" name="TextBox 16"/>
+          <p:cNvSpPr txBox="1"/>
+          <p:nvPr/>
+        </p:nvSpPr>
+        <p:spPr>
+          <a:xfrm>
+            <a:off x="5029200" y="2295144"/>
+            <a:ext cx="6583680" cy="502920"/>
+          </a:xfrm>
+          <a:prstGeom prst="rect">
+            <a:avLst/>
+          </a:prstGeom>
+          <a:noFill/>
+        </p:spPr>
+        <p:txBody>
+          <a:bodyPr wrap="square" anchor="t" lIns="0" rIns="0" tIns="0" bIns="0">
+            <a:spAutoFit/>
+          </a:bodyPr>
+          <a:lstStyle/>
+          <a:p>
+            <a:pPr algn="l">
+              <a:lnSpc>
+                <a:spcPct val="108000"/>
+              </a:lnSpc>
+              <a:spcAft>
+                <a:spcPts val="0"/>
+              </a:spcAft>
+            </a:pPr>
+            <a:r>
+              <a:rPr sz="1150" b="0" i="0">
+                <a:solidFill>
+                  <a:srgbClr val="B9C5D4"/>
+                </a:solidFill>
+                <a:latin typeface="Noto Sans CJK SC"/>
+                <a:ea typeface="Noto Sans CJK SC"/>
+              </a:rPr>
+              <a:t>完全一致：同为碳晶体、莫氏硬度 10、同等火彩，肉眼与常规仪器无法区分</a:t>
+            </a:r>
+          </a:p>
+        </p:txBody>
+      </p:sp>
+      <p:sp>
+        <p:nvSpPr>
+          <p:cNvPr id="18" name="Rounded Rectangle 17"/>
+          <p:cNvSpPr/>
+          <p:nvPr/>
+        </p:nvSpPr>
+        <p:spPr>
+          <a:xfrm>
+            <a:off x="5029200" y="2898648"/>
+            <a:ext cx="6583680" cy="566928"/>
+          </a:xfrm>
+          <a:prstGeom prst="roundRect">
+            <a:avLst>
+              <a:gd name="adj" fmla="val 18000"/>
+            </a:avLst>
+          </a:prstGeom>
+          <a:solidFill>
+            <a:srgbClr val="1E3D5C"/>
+          </a:solidFill>
+          <a:ln>
+            <a:noFill/>
+          </a:ln>
+          <a:effectLst/>
+        </p:spPr>
+        <p:style>
+          <a:lnRef idx="1">
+            <a:schemeClr val="accent1"/>
+          </a:lnRef>
+          <a:fillRef idx="3">
+            <a:schemeClr val="accent1"/>
+          </a:fillRef>
+          <a:effectRef idx="2">
+            <a:schemeClr val="accent1"/>
+          </a:effectRef>
+          <a:fontRef idx="minor">
+            <a:schemeClr val="lt1"/>
+          </a:fontRef>
+        </p:style>
+        <p:txBody>
+          <a:bodyPr rtlCol="0" anchor="ctr"/>
+          <a:lstStyle/>
+          <a:p>
+            <a:pPr algn="ctr"/>
+          </a:p>
+        </p:txBody>
+      </p:sp>
+      <p:sp>
+        <p:nvSpPr>
+          <p:cNvPr id="19" name="Rounded Rectangle 18"/>
+          <p:cNvSpPr/>
+          <p:nvPr/>
+        </p:nvSpPr>
+        <p:spPr>
+          <a:xfrm>
+            <a:off x="5029200" y="2898648"/>
+            <a:ext cx="1234440" cy="566928"/>
+          </a:xfrm>
+          <a:prstGeom prst="roundRect">
+            <a:avLst>
+              <a:gd name="adj" fmla="val 18000"/>
+            </a:avLst>
+          </a:prstGeom>
+          <a:solidFill>
+            <a:srgbClr val="C9A24B"/>
+          </a:solidFill>
+          <a:ln>
+            <a:noFill/>
+          </a:ln>
+          <a:effectLst/>
+        </p:spPr>
+        <p:style>
+          <a:lnRef idx="1">
+            <a:schemeClr val="accent1"/>
+          </a:lnRef>
+          <a:fillRef idx="3">
+            <a:schemeClr val="accent1"/>
+          </a:fillRef>
+          <a:effectRef idx="2">
+            <a:schemeClr val="accent1"/>
+          </a:effectRef>
+          <a:fontRef idx="minor">
+            <a:schemeClr val="lt1"/>
+          </a:fontRef>
+        </p:style>
+        <p:txBody>
+          <a:bodyPr rtlCol="0" anchor="ctr"/>
+          <a:lstStyle/>
+          <a:p>
+            <a:pPr algn="ctr"/>
+          </a:p>
+        </p:txBody>
+      </p:sp>
+      <p:sp>
+        <p:nvSpPr>
+          <p:cNvPr id="20" name="TextBox 19"/>
+          <p:cNvSpPr txBox="1"/>
+          <p:nvPr/>
+        </p:nvSpPr>
+        <p:spPr>
+          <a:xfrm>
+            <a:off x="5093208" y="2898648"/>
+            <a:ext cx="1115568" cy="566928"/>
+          </a:xfrm>
+          <a:prstGeom prst="rect">
+            <a:avLst/>
+          </a:prstGeom>
+          <a:noFill/>
+        </p:spPr>
+        <p:txBody>
+          <a:bodyPr wrap="square" anchor="ctr" lIns="0" rIns="0" tIns="0" bIns="0">
+            <a:spAutoFit/>
+          </a:bodyPr>
+          <a:lstStyle/>
+          <a:p>
+            <a:pPr algn="ctr">
+              <a:lnSpc>
+                <a:spcPct val="100000"/>
+              </a:lnSpc>
+              <a:spcAft>
+                <a:spcPts val="600"/>
+              </a:spcAft>
+            </a:pPr>
+            <a:r>
+              <a:rPr sz="1350" b="1" i="0">
+                <a:solidFill>
+                  <a:srgbClr val="FFFFFF"/>
+                </a:solidFill>
+                <a:latin typeface="Noto Sans CJK SC"/>
+                <a:ea typeface="Noto Sans CJK SC"/>
+              </a:rPr>
+              <a:t>1/3~1/5</a:t>
+            </a:r>
+          </a:p>
+        </p:txBody>
+      </p:sp>
+      <p:sp>
+        <p:nvSpPr>
+          <p:cNvPr id="21" name="TextBox 20"/>
+          <p:cNvSpPr txBox="1"/>
+          <p:nvPr/>
+        </p:nvSpPr>
+        <p:spPr>
+          <a:xfrm>
+            <a:off x="6400800" y="2898648"/>
+            <a:ext cx="5120640" cy="566928"/>
+          </a:xfrm>
+          <a:prstGeom prst="rect">
+            <a:avLst/>
+          </a:prstGeom>
+          <a:noFill/>
+        </p:spPr>
+        <p:txBody>
+          <a:bodyPr wrap="square" anchor="ctr" lIns="0" rIns="0" tIns="0" bIns="0">
+            <a:spAutoFit/>
+          </a:bodyPr>
+          <a:lstStyle/>
+          <a:p>
+            <a:pPr algn="l">
+              <a:lnSpc>
+                <a:spcPct val="100000"/>
+              </a:lnSpc>
+              <a:spcAft>
+                <a:spcPts val="0"/>
+              </a:spcAft>
+            </a:pPr>
+            <a:r>
+              <a:rPr sz="1450" b="1" i="0">
+                <a:solidFill>
+                  <a:srgbClr val="FFFFFF"/>
+                </a:solidFill>
+                <a:latin typeface="Noto Sans CJK SC"/>
+                <a:ea typeface="Noto Sans CJK SC"/>
+              </a:rPr>
+              <a:t>价格</a:t>
+            </a:r>
+          </a:p>
+        </p:txBody>
+      </p:sp>
+      <p:sp>
+        <p:nvSpPr>
+          <p:cNvPr id="22" name="TextBox 21"/>
+          <p:cNvSpPr txBox="1"/>
+          <p:nvPr/>
+        </p:nvSpPr>
+        <p:spPr>
+          <a:xfrm>
+            <a:off x="5029200" y="3502152"/>
+            <a:ext cx="6583680" cy="502920"/>
+          </a:xfrm>
+          <a:prstGeom prst="rect">
+            <a:avLst/>
+          </a:prstGeom>
+          <a:noFill/>
+        </p:spPr>
+        <p:txBody>
+          <a:bodyPr wrap="square" anchor="t" lIns="0" rIns="0" tIns="0" bIns="0">
+            <a:spAutoFit/>
+          </a:bodyPr>
+          <a:lstStyle/>
+          <a:p>
+            <a:pPr algn="l">
+              <a:lnSpc>
+                <a:spcPct val="108000"/>
+              </a:lnSpc>
+              <a:spcAft>
+                <a:spcPts val="0"/>
+              </a:spcAft>
+            </a:pPr>
+            <a:r>
+              <a:rPr sz="1150" b="0" i="0">
+                <a:solidFill>
+                  <a:srgbClr val="B9C5D4"/>
+                </a:solidFill>
+                <a:latin typeface="Noto Sans CJK SC"/>
+                <a:ea typeface="Noto Sans CJK SC"/>
+              </a:rPr>
+              <a:t>培育钻仅为天然钻的 1/3 ~ 1/5：同样预算，克拉数翻倍</a:t>
+            </a:r>
+          </a:p>
+        </p:txBody>
+      </p:sp>
+      <p:sp>
+        <p:nvSpPr>
+          <p:cNvPr id="23" name="Rounded Rectangle 22"/>
+          <p:cNvSpPr/>
+          <p:nvPr/>
+        </p:nvSpPr>
+        <p:spPr>
+          <a:xfrm>
+            <a:off x="5029200" y="4105656"/>
+            <a:ext cx="6583680" cy="566928"/>
+          </a:xfrm>
+          <a:prstGeom prst="roundRect">
+            <a:avLst>
+              <a:gd name="adj" fmla="val 18000"/>
+            </a:avLst>
+          </a:prstGeom>
+          <a:solidFill>
+            <a:srgbClr val="1E3D5C"/>
+          </a:solidFill>
+          <a:ln>
+            <a:noFill/>
+          </a:ln>
+          <a:effectLst/>
+        </p:spPr>
+        <p:style>
+          <a:lnRef idx="1">
+            <a:schemeClr val="accent1"/>
+          </a:lnRef>
+          <a:fillRef idx="3">
+            <a:schemeClr val="accent1"/>
+          </a:fillRef>
+          <a:effectRef idx="2">
+            <a:schemeClr val="accent1"/>
+          </a:effectRef>
+          <a:fontRef idx="minor">
+            <a:schemeClr val="lt1"/>
+          </a:fontRef>
+        </p:style>
+        <p:txBody>
+          <a:bodyPr rtlCol="0" anchor="ctr"/>
+          <a:lstStyle/>
+          <a:p>
+            <a:pPr algn="ctr"/>
+          </a:p>
+        </p:txBody>
+      </p:sp>
+      <p:sp>
+        <p:nvSpPr>
+          <p:cNvPr id="24" name="Rounded Rectangle 23"/>
+          <p:cNvSpPr/>
+          <p:nvPr/>
+        </p:nvSpPr>
+        <p:spPr>
+          <a:xfrm>
+            <a:off x="5029200" y="4105656"/>
+            <a:ext cx="1234440" cy="566928"/>
+          </a:xfrm>
+          <a:prstGeom prst="roundRect">
+            <a:avLst>
+              <a:gd name="adj" fmla="val 18000"/>
+            </a:avLst>
+          </a:prstGeom>
+          <a:solidFill>
+            <a:srgbClr val="B03A2E"/>
+          </a:solidFill>
+          <a:ln>
+            <a:noFill/>
+          </a:ln>
+          <a:effectLst/>
+        </p:spPr>
+        <p:style>
+          <a:lnRef idx="1">
+            <a:schemeClr val="accent1"/>
+          </a:lnRef>
+          <a:fillRef idx="3">
+            <a:schemeClr val="accent1"/>
+          </a:fillRef>
+          <a:effectRef idx="2">
+            <a:schemeClr val="accent1"/>
+          </a:effectRef>
+          <a:fontRef idx="minor">
+            <a:schemeClr val="lt1"/>
+          </a:fontRef>
+        </p:style>
+        <p:txBody>
+          <a:bodyPr rtlCol="0" anchor="ctr"/>
+          <a:lstStyle/>
+          <a:p>
+            <a:pPr algn="ctr"/>
+          </a:p>
+        </p:txBody>
+      </p:sp>
+      <p:sp>
+        <p:nvSpPr>
+          <p:cNvPr id="25" name="TextBox 24"/>
+          <p:cNvSpPr txBox="1"/>
+          <p:nvPr/>
+        </p:nvSpPr>
+        <p:spPr>
+          <a:xfrm>
+            <a:off x="5093208" y="4105656"/>
+            <a:ext cx="1115568" cy="566928"/>
+          </a:xfrm>
+          <a:prstGeom prst="rect">
+            <a:avLst/>
+          </a:prstGeom>
+          <a:noFill/>
+        </p:spPr>
+        <p:txBody>
+          <a:bodyPr wrap="square" anchor="ctr" lIns="0" rIns="0" tIns="0" bIns="0">
+            <a:spAutoFit/>
+          </a:bodyPr>
+          <a:lstStyle/>
+          <a:p>
+            <a:pPr algn="ctr">
+              <a:lnSpc>
+                <a:spcPct val="100000"/>
+              </a:lnSpc>
+              <a:spcAft>
+                <a:spcPts val="600"/>
+              </a:spcAft>
+            </a:pPr>
+            <a:r>
+              <a:rPr sz="1350" b="1" i="0">
+                <a:solidFill>
+                  <a:srgbClr val="FFFFFF"/>
+                </a:solidFill>
+                <a:latin typeface="Noto Sans CJK SC"/>
+                <a:ea typeface="Noto Sans CJK SC"/>
+              </a:rPr>
+              <a:t>无上限</a:t>
+            </a:r>
+          </a:p>
+        </p:txBody>
+      </p:sp>
+      <p:sp>
+        <p:nvSpPr>
+          <p:cNvPr id="26" name="TextBox 25"/>
+          <p:cNvSpPr txBox="1"/>
+          <p:nvPr/>
+        </p:nvSpPr>
+        <p:spPr>
+          <a:xfrm>
+            <a:off x="6400800" y="4105656"/>
+            <a:ext cx="5120640" cy="566928"/>
+          </a:xfrm>
+          <a:prstGeom prst="rect">
+            <a:avLst/>
+          </a:prstGeom>
+          <a:noFill/>
+        </p:spPr>
+        <p:txBody>
+          <a:bodyPr wrap="square" anchor="ctr" lIns="0" rIns="0" tIns="0" bIns="0">
+            <a:spAutoFit/>
+          </a:bodyPr>
+          <a:lstStyle/>
+          <a:p>
+            <a:pPr algn="l">
+              <a:lnSpc>
+                <a:spcPct val="100000"/>
+              </a:lnSpc>
+              <a:spcAft>
+                <a:spcPts val="0"/>
+              </a:spcAft>
+            </a:pPr>
+            <a:r>
+              <a:rPr sz="1450" b="1" i="0">
+                <a:solidFill>
+                  <a:srgbClr val="FFFFFF"/>
+                </a:solidFill>
+                <a:latin typeface="Noto Sans CJK SC"/>
+                <a:ea typeface="Noto Sans CJK SC"/>
+              </a:rPr>
+              <a:t>供给能力</a:t>
+            </a:r>
+          </a:p>
+        </p:txBody>
+      </p:sp>
+      <p:sp>
+        <p:nvSpPr>
+          <p:cNvPr id="27" name="TextBox 26"/>
+          <p:cNvSpPr txBox="1"/>
+          <p:nvPr/>
+        </p:nvSpPr>
+        <p:spPr>
+          <a:xfrm>
+            <a:off x="5029200" y="4709160"/>
+            <a:ext cx="6583680" cy="502920"/>
+          </a:xfrm>
+          <a:prstGeom prst="rect">
+            <a:avLst/>
+          </a:prstGeom>
+          <a:noFill/>
+        </p:spPr>
+        <p:txBody>
+          <a:bodyPr wrap="square" anchor="t" lIns="0" rIns="0" tIns="0" bIns="0">
+            <a:spAutoFit/>
+          </a:bodyPr>
+          <a:lstStyle/>
+          <a:p>
+            <a:pPr algn="l">
+              <a:lnSpc>
+                <a:spcPct val="108000"/>
+              </a:lnSpc>
+              <a:spcAft>
+                <a:spcPts val="0"/>
+              </a:spcAft>
+            </a:pPr>
+            <a:r>
+              <a:rPr sz="1150" b="0" i="0">
+                <a:solidFill>
+                  <a:srgbClr val="B9C5D4"/>
+                </a:solidFill>
+                <a:latin typeface="Noto Sans CJK SC"/>
+                <a:ea typeface="Noto Sans CJK SC"/>
+              </a:rPr>
+              <a:t>天然钻依赖矿产开采、储量有限；培育钻可规模化量产、成本持续下降</a:t>
+            </a:r>
+          </a:p>
+        </p:txBody>
+      </p:sp>
+      <p:sp>
+        <p:nvSpPr>
+          <p:cNvPr id="28" name="Rounded Rectangle 27"/>
+          <p:cNvSpPr/>
+          <p:nvPr/>
+        </p:nvSpPr>
+        <p:spPr>
+          <a:xfrm>
+            <a:off x="5029200" y="5321808"/>
+            <a:ext cx="6583680" cy="475488"/>
+          </a:xfrm>
+          <a:prstGeom prst="roundRect">
+            <a:avLst>
+              <a:gd name="adj" fmla="val 25000"/>
             </a:avLst>
           </a:prstGeom>
           <a:solidFill>
@@ -7367,593 +8323,71 @@
       </p:sp>
       <p:sp>
         <p:nvSpPr>
-          <p:cNvPr id="7" name="Diamond 6"/>
+          <p:cNvPr id="29" name="TextBox 28"/>
+          <p:cNvSpPr txBox="1"/>
+          <p:nvPr/>
+        </p:nvSpPr>
+        <p:spPr>
+          <a:xfrm>
+            <a:off x="5257800" y="5321808"/>
+            <a:ext cx="6126480" cy="475488"/>
+          </a:xfrm>
+          <a:prstGeom prst="rect">
+            <a:avLst/>
+          </a:prstGeom>
+          <a:noFill/>
+        </p:spPr>
+        <p:txBody>
+          <a:bodyPr wrap="square" anchor="ctr" lIns="0" rIns="0" tIns="0" bIns="0">
+            <a:spAutoFit/>
+          </a:bodyPr>
+          <a:lstStyle/>
+          <a:p>
+            <a:pPr algn="l">
+              <a:lnSpc>
+                <a:spcPct val="100000"/>
+              </a:lnSpc>
+              <a:spcAft>
+                <a:spcPts val="0"/>
+              </a:spcAft>
+            </a:pPr>
+            <a:r>
+              <a:rPr sz="1250" b="1" i="0">
+                <a:solidFill>
+                  <a:srgbClr val="C9A24B"/>
+                </a:solidFill>
+                <a:latin typeface="Noto Sans CJK SC"/>
+                <a:ea typeface="Noto Sans CJK SC"/>
+              </a:rPr>
+              <a:t>美国市场信号：</a:t>
+            </a:r>
+            <a:r>
+              <a:rPr sz="1250" b="0" i="0">
+                <a:solidFill>
+                  <a:srgbClr val="FFFFFF"/>
+                </a:solidFill>
+                <a:latin typeface="Noto Sans CJK SC"/>
+                <a:ea typeface="Noto Sans CJK SC"/>
+              </a:rPr>
+              <a:t>培育钻在订婚戒中的渗透率逐年快速提升——年轻一代已用钱包投票</a:t>
+            </a:r>
+          </a:p>
+        </p:txBody>
+      </p:sp>
+      <p:sp>
+        <p:nvSpPr>
+          <p:cNvPr id="30" name="Rounded Rectangle 29"/>
           <p:cNvSpPr/>
           <p:nvPr/>
         </p:nvSpPr>
         <p:spPr>
           <a:xfrm>
-            <a:off x="1897380" y="2098548"/>
-            <a:ext cx="502920" cy="502920"/>
-          </a:xfrm>
-          <a:prstGeom prst="diamond">
-            <a:avLst/>
-          </a:prstGeom>
-          <a:solidFill>
-            <a:srgbClr val="FFFFFF"/>
-          </a:solidFill>
-          <a:ln>
-            <a:noFill/>
-          </a:ln>
-          <a:effectLst/>
-        </p:spPr>
-        <p:style>
-          <a:lnRef idx="1">
-            <a:schemeClr val="accent1"/>
-          </a:lnRef>
-          <a:fillRef idx="3">
-            <a:schemeClr val="accent1"/>
-          </a:fillRef>
-          <a:effectRef idx="2">
-            <a:schemeClr val="accent1"/>
-          </a:effectRef>
-          <a:fontRef idx="minor">
-            <a:schemeClr val="lt1"/>
-          </a:fontRef>
-        </p:style>
-        <p:txBody>
-          <a:bodyPr rtlCol="0" anchor="ctr"/>
-          <a:lstStyle/>
-          <a:p>
-            <a:pPr algn="ctr"/>
-          </a:p>
-        </p:txBody>
-      </p:sp>
-      <p:sp>
-        <p:nvSpPr>
-          <p:cNvPr id="8" name="TextBox 7"/>
-          <p:cNvSpPr txBox="1"/>
-          <p:nvPr/>
-        </p:nvSpPr>
-        <p:spPr>
-          <a:xfrm>
-            <a:off x="1005840" y="2770632"/>
-            <a:ext cx="2286000" cy="457200"/>
-          </a:xfrm>
-          <a:prstGeom prst="rect">
-            <a:avLst/>
-          </a:prstGeom>
-          <a:noFill/>
-        </p:spPr>
-        <p:txBody>
-          <a:bodyPr wrap="square" anchor="t" lIns="0" rIns="0" tIns="0" bIns="0">
-            <a:spAutoFit/>
-          </a:bodyPr>
-          <a:lstStyle/>
-          <a:p>
-            <a:pPr algn="ctr">
-              <a:lnSpc>
-                <a:spcPct val="100000"/>
-              </a:lnSpc>
-              <a:spcAft>
-                <a:spcPts val="600"/>
-              </a:spcAft>
-            </a:pPr>
-            <a:r>
-              <a:rPr sz="1700" b="1" i="0">
-                <a:solidFill>
-                  <a:srgbClr val="FFFFFF"/>
-                </a:solidFill>
-                <a:latin typeface="Noto Sans CJK SC"/>
-                <a:ea typeface="Noto Sans CJK SC"/>
-              </a:rPr>
-              <a:t>天然钻石</a:t>
-            </a:r>
-          </a:p>
-        </p:txBody>
-      </p:sp>
-      <p:sp>
-        <p:nvSpPr>
-          <p:cNvPr id="9" name="TextBox 8"/>
-          <p:cNvSpPr txBox="1"/>
-          <p:nvPr/>
-        </p:nvSpPr>
-        <p:spPr>
-          <a:xfrm>
-            <a:off x="1005840" y="3209544"/>
-            <a:ext cx="2286000" cy="411480"/>
-          </a:xfrm>
-          <a:prstGeom prst="rect">
-            <a:avLst/>
-          </a:prstGeom>
-          <a:noFill/>
-        </p:spPr>
-        <p:txBody>
-          <a:bodyPr wrap="square" anchor="t" lIns="0" rIns="0" tIns="0" bIns="0">
-            <a:spAutoFit/>
-          </a:bodyPr>
-          <a:lstStyle/>
-          <a:p>
-            <a:pPr algn="ctr">
-              <a:lnSpc>
-                <a:spcPct val="100000"/>
-              </a:lnSpc>
-              <a:spcAft>
-                <a:spcPts val="600"/>
-              </a:spcAft>
-            </a:pPr>
-            <a:r>
-              <a:rPr sz="1200" b="0" i="0">
-                <a:solidFill>
-                  <a:srgbClr val="E8D5A3"/>
-                </a:solidFill>
-                <a:latin typeface="Noto Sans CJK SC"/>
-                <a:ea typeface="Noto Sans CJK SC"/>
-              </a:rPr>
-              <a:t>地下 10 亿年形成</a:t>
-            </a:r>
-          </a:p>
-        </p:txBody>
-      </p:sp>
-      <p:sp>
-        <p:nvSpPr>
-          <p:cNvPr id="10" name="Rounded Rectangle 9"/>
-          <p:cNvSpPr/>
-          <p:nvPr/>
-        </p:nvSpPr>
-        <p:spPr>
-          <a:xfrm>
-            <a:off x="3703320" y="1783080"/>
-            <a:ext cx="2560320" cy="1920240"/>
+            <a:off x="868680" y="5870448"/>
+            <a:ext cx="10744200" cy="749808"/>
           </a:xfrm>
           <a:prstGeom prst="roundRect">
             <a:avLst>
-              <a:gd name="adj" fmla="val 8000"/>
-            </a:avLst>
-          </a:prstGeom>
-          <a:solidFill>
-            <a:srgbClr val="8A6D2F"/>
-          </a:solidFill>
-          <a:ln w="12700">
-            <a:solidFill>
-              <a:srgbClr val="C9A24B"/>
-            </a:solidFill>
-          </a:ln>
-          <a:effectLst/>
-        </p:spPr>
-        <p:style>
-          <a:lnRef idx="1">
-            <a:schemeClr val="accent1"/>
-          </a:lnRef>
-          <a:fillRef idx="3">
-            <a:schemeClr val="accent1"/>
-          </a:fillRef>
-          <a:effectRef idx="2">
-            <a:schemeClr val="accent1"/>
-          </a:effectRef>
-          <a:fontRef idx="minor">
-            <a:schemeClr val="lt1"/>
-          </a:fontRef>
-        </p:style>
-        <p:txBody>
-          <a:bodyPr rtlCol="0" anchor="ctr"/>
-          <a:lstStyle/>
-          <a:p>
-            <a:pPr algn="ctr"/>
-          </a:p>
-        </p:txBody>
-      </p:sp>
-      <p:sp>
-        <p:nvSpPr>
-          <p:cNvPr id="11" name="Diamond 10"/>
-          <p:cNvSpPr/>
-          <p:nvPr/>
-        </p:nvSpPr>
-        <p:spPr>
-          <a:xfrm>
-            <a:off x="4732020" y="2098548"/>
-            <a:ext cx="502920" cy="502920"/>
-          </a:xfrm>
-          <a:prstGeom prst="diamond">
-            <a:avLst/>
-          </a:prstGeom>
-          <a:solidFill>
-            <a:srgbClr val="FFFFFF"/>
-          </a:solidFill>
-          <a:ln>
-            <a:noFill/>
-          </a:ln>
-          <a:effectLst/>
-        </p:spPr>
-        <p:style>
-          <a:lnRef idx="1">
-            <a:schemeClr val="accent1"/>
-          </a:lnRef>
-          <a:fillRef idx="3">
-            <a:schemeClr val="accent1"/>
-          </a:fillRef>
-          <a:effectRef idx="2">
-            <a:schemeClr val="accent1"/>
-          </a:effectRef>
-          <a:fontRef idx="minor">
-            <a:schemeClr val="lt1"/>
-          </a:fontRef>
-        </p:style>
-        <p:txBody>
-          <a:bodyPr rtlCol="0" anchor="ctr"/>
-          <a:lstStyle/>
-          <a:p>
-            <a:pPr algn="ctr"/>
-          </a:p>
-        </p:txBody>
-      </p:sp>
-      <p:sp>
-        <p:nvSpPr>
-          <p:cNvPr id="12" name="TextBox 11"/>
-          <p:cNvSpPr txBox="1"/>
-          <p:nvPr/>
-        </p:nvSpPr>
-        <p:spPr>
-          <a:xfrm>
-            <a:off x="3840480" y="2770632"/>
-            <a:ext cx="2286000" cy="457200"/>
-          </a:xfrm>
-          <a:prstGeom prst="rect">
-            <a:avLst/>
-          </a:prstGeom>
-          <a:noFill/>
-        </p:spPr>
-        <p:txBody>
-          <a:bodyPr wrap="square" anchor="t" lIns="0" rIns="0" tIns="0" bIns="0">
-            <a:spAutoFit/>
-          </a:bodyPr>
-          <a:lstStyle/>
-          <a:p>
-            <a:pPr algn="ctr">
-              <a:lnSpc>
-                <a:spcPct val="100000"/>
-              </a:lnSpc>
-              <a:spcAft>
-                <a:spcPts val="600"/>
-              </a:spcAft>
-            </a:pPr>
-            <a:r>
-              <a:rPr sz="1700" b="1" i="0">
-                <a:solidFill>
-                  <a:srgbClr val="FFFFFF"/>
-                </a:solidFill>
-                <a:latin typeface="Noto Sans CJK SC"/>
-                <a:ea typeface="Noto Sans CJK SC"/>
-              </a:rPr>
-              <a:t>培育钻石</a:t>
-            </a:r>
-          </a:p>
-        </p:txBody>
-      </p:sp>
-      <p:sp>
-        <p:nvSpPr>
-          <p:cNvPr id="13" name="TextBox 12"/>
-          <p:cNvSpPr txBox="1"/>
-          <p:nvPr/>
-        </p:nvSpPr>
-        <p:spPr>
-          <a:xfrm>
-            <a:off x="3840480" y="3209544"/>
-            <a:ext cx="2286000" cy="411480"/>
-          </a:xfrm>
-          <a:prstGeom prst="rect">
-            <a:avLst/>
-          </a:prstGeom>
-          <a:noFill/>
-        </p:spPr>
-        <p:txBody>
-          <a:bodyPr wrap="square" anchor="t" lIns="0" rIns="0" tIns="0" bIns="0">
-            <a:spAutoFit/>
-          </a:bodyPr>
-          <a:lstStyle/>
-          <a:p>
-            <a:pPr algn="ctr">
-              <a:lnSpc>
-                <a:spcPct val="100000"/>
-              </a:lnSpc>
-              <a:spcAft>
-                <a:spcPts val="600"/>
-              </a:spcAft>
-            </a:pPr>
-            <a:r>
-              <a:rPr sz="1200" b="0" i="0">
-                <a:solidFill>
-                  <a:srgbClr val="E8D5A3"/>
-                </a:solidFill>
-                <a:latin typeface="Noto Sans CJK SC"/>
-                <a:ea typeface="Noto Sans CJK SC"/>
-              </a:rPr>
-              <a:t>实验室 2~4 周培育</a:t>
-            </a:r>
-          </a:p>
-        </p:txBody>
-      </p:sp>
-      <p:sp>
-        <p:nvSpPr>
-          <p:cNvPr id="14" name="Rounded Rectangle 13"/>
-          <p:cNvSpPr/>
-          <p:nvPr/>
-        </p:nvSpPr>
-        <p:spPr>
-          <a:xfrm>
-            <a:off x="6720840" y="1783080"/>
-            <a:ext cx="4892040" cy="566928"/>
-          </a:xfrm>
-          <a:prstGeom prst="roundRect">
-            <a:avLst>
-              <a:gd name="adj" fmla="val 18000"/>
-            </a:avLst>
-          </a:prstGeom>
-          <a:solidFill>
-            <a:srgbClr val="1E3D5C"/>
-          </a:solidFill>
-          <a:ln>
-            <a:noFill/>
-          </a:ln>
-          <a:effectLst/>
-        </p:spPr>
-        <p:style>
-          <a:lnRef idx="1">
-            <a:schemeClr val="accent1"/>
-          </a:lnRef>
-          <a:fillRef idx="3">
-            <a:schemeClr val="accent1"/>
-          </a:fillRef>
-          <a:effectRef idx="2">
-            <a:schemeClr val="accent1"/>
-          </a:effectRef>
-          <a:fontRef idx="minor">
-            <a:schemeClr val="lt1"/>
-          </a:fontRef>
-        </p:style>
-        <p:txBody>
-          <a:bodyPr rtlCol="0" anchor="ctr"/>
-          <a:lstStyle/>
-          <a:p>
-            <a:pPr algn="ctr"/>
-          </a:p>
-        </p:txBody>
-      </p:sp>
-      <p:sp>
-        <p:nvSpPr>
-          <p:cNvPr id="15" name="Rounded Rectangle 14"/>
-          <p:cNvSpPr/>
-          <p:nvPr/>
-        </p:nvSpPr>
-        <p:spPr>
-          <a:xfrm>
-            <a:off x="6720840" y="1783080"/>
-            <a:ext cx="1234440" cy="566928"/>
-          </a:xfrm>
-          <a:prstGeom prst="roundRect">
-            <a:avLst>
-              <a:gd name="adj" fmla="val 18000"/>
-            </a:avLst>
-          </a:prstGeom>
-          <a:solidFill>
-            <a:srgbClr val="2E7D52"/>
-          </a:solidFill>
-          <a:ln>
-            <a:noFill/>
-          </a:ln>
-          <a:effectLst/>
-        </p:spPr>
-        <p:style>
-          <a:lnRef idx="1">
-            <a:schemeClr val="accent1"/>
-          </a:lnRef>
-          <a:fillRef idx="3">
-            <a:schemeClr val="accent1"/>
-          </a:fillRef>
-          <a:effectRef idx="2">
-            <a:schemeClr val="accent1"/>
-          </a:effectRef>
-          <a:fontRef idx="minor">
-            <a:schemeClr val="lt1"/>
-          </a:fontRef>
-        </p:style>
-        <p:txBody>
-          <a:bodyPr rtlCol="0" anchor="ctr"/>
-          <a:lstStyle/>
-          <a:p>
-            <a:pPr algn="ctr"/>
-          </a:p>
-        </p:txBody>
-      </p:sp>
-      <p:sp>
-        <p:nvSpPr>
-          <p:cNvPr id="16" name="TextBox 15"/>
-          <p:cNvSpPr txBox="1"/>
-          <p:nvPr/>
-        </p:nvSpPr>
-        <p:spPr>
-          <a:xfrm>
-            <a:off x="6784848" y="1783080"/>
-            <a:ext cx="1115568" cy="566928"/>
-          </a:xfrm>
-          <a:prstGeom prst="rect">
-            <a:avLst/>
-          </a:prstGeom>
-          <a:noFill/>
-        </p:spPr>
-        <p:txBody>
-          <a:bodyPr wrap="square" anchor="ctr" lIns="0" rIns="0" tIns="0" bIns="0">
-            <a:spAutoFit/>
-          </a:bodyPr>
-          <a:lstStyle/>
-          <a:p>
-            <a:pPr algn="ctr">
-              <a:lnSpc>
-                <a:spcPct val="100000"/>
-              </a:lnSpc>
-              <a:spcAft>
-                <a:spcPts val="600"/>
-              </a:spcAft>
-            </a:pPr>
-            <a:r>
-              <a:rPr sz="1350" b="1" i="0">
-                <a:solidFill>
-                  <a:srgbClr val="FFFFFF"/>
-                </a:solidFill>
-                <a:latin typeface="Noto Sans CJK SC"/>
-                <a:ea typeface="Noto Sans CJK SC"/>
-              </a:rPr>
-              <a:t>相同</a:t>
-            </a:r>
-          </a:p>
-        </p:txBody>
-      </p:sp>
-      <p:sp>
-        <p:nvSpPr>
-          <p:cNvPr id="17" name="TextBox 16"/>
-          <p:cNvSpPr txBox="1"/>
-          <p:nvPr/>
-        </p:nvSpPr>
-        <p:spPr>
-          <a:xfrm>
-            <a:off x="8092440" y="1783080"/>
-            <a:ext cx="3474720" cy="566928"/>
-          </a:xfrm>
-          <a:prstGeom prst="rect">
-            <a:avLst/>
-          </a:prstGeom>
-          <a:noFill/>
-        </p:spPr>
-        <p:txBody>
-          <a:bodyPr wrap="square" anchor="ctr" lIns="0" rIns="0" tIns="0" bIns="0">
-            <a:spAutoFit/>
-          </a:bodyPr>
-          <a:lstStyle/>
-          <a:p>
-            <a:pPr algn="l">
-              <a:lnSpc>
-                <a:spcPct val="100000"/>
-              </a:lnSpc>
-              <a:spcAft>
-                <a:spcPts val="0"/>
-              </a:spcAft>
-            </a:pPr>
-            <a:r>
-              <a:rPr sz="1450" b="1" i="0">
-                <a:solidFill>
-                  <a:srgbClr val="FFFFFF"/>
-                </a:solidFill>
-                <a:latin typeface="Noto Sans CJK SC"/>
-                <a:ea typeface="Noto Sans CJK SC"/>
-              </a:rPr>
-              <a:t>视觉 · 化学结构 · 硬度</a:t>
-            </a:r>
-          </a:p>
-        </p:txBody>
-      </p:sp>
-      <p:sp>
-        <p:nvSpPr>
-          <p:cNvPr id="18" name="TextBox 17"/>
-          <p:cNvSpPr txBox="1"/>
-          <p:nvPr/>
-        </p:nvSpPr>
-        <p:spPr>
-          <a:xfrm>
-            <a:off x="6720840" y="2386584"/>
-            <a:ext cx="4892040" cy="566928"/>
-          </a:xfrm>
-          <a:prstGeom prst="rect">
-            <a:avLst/>
-          </a:prstGeom>
-          <a:noFill/>
-        </p:spPr>
-        <p:txBody>
-          <a:bodyPr wrap="square" anchor="t" lIns="0" rIns="0" tIns="0" bIns="0">
-            <a:spAutoFit/>
-          </a:bodyPr>
-          <a:lstStyle/>
-          <a:p>
-            <a:pPr algn="l">
-              <a:lnSpc>
-                <a:spcPct val="108000"/>
-              </a:lnSpc>
-              <a:spcAft>
-                <a:spcPts val="0"/>
-              </a:spcAft>
-            </a:pPr>
-            <a:r>
-              <a:rPr sz="1150" b="0" i="0">
-                <a:solidFill>
-                  <a:srgbClr val="B9C5D4"/>
-                </a:solidFill>
-                <a:latin typeface="Noto Sans CJK SC"/>
-                <a:ea typeface="Noto Sans CJK SC"/>
-              </a:rPr>
-              <a:t>完全一致：同为碳晶体、莫氏硬度 10、同等火彩，肉眼与常规仪器无法区分</a:t>
-            </a:r>
-          </a:p>
-        </p:txBody>
-      </p:sp>
-      <p:sp>
-        <p:nvSpPr>
-          <p:cNvPr id="19" name="Rounded Rectangle 18"/>
-          <p:cNvSpPr/>
-          <p:nvPr/>
-        </p:nvSpPr>
-        <p:spPr>
-          <a:xfrm>
-            <a:off x="6720840" y="3081528"/>
-            <a:ext cx="4892040" cy="566928"/>
-          </a:xfrm>
-          <a:prstGeom prst="roundRect">
-            <a:avLst>
-              <a:gd name="adj" fmla="val 18000"/>
-            </a:avLst>
-          </a:prstGeom>
-          <a:solidFill>
-            <a:srgbClr val="1E3D5C"/>
-          </a:solidFill>
-          <a:ln>
-            <a:noFill/>
-          </a:ln>
-          <a:effectLst/>
-        </p:spPr>
-        <p:style>
-          <a:lnRef idx="1">
-            <a:schemeClr val="accent1"/>
-          </a:lnRef>
-          <a:fillRef idx="3">
-            <a:schemeClr val="accent1"/>
-          </a:fillRef>
-          <a:effectRef idx="2">
-            <a:schemeClr val="accent1"/>
-          </a:effectRef>
-          <a:fontRef idx="minor">
-            <a:schemeClr val="lt1"/>
-          </a:fontRef>
-        </p:style>
-        <p:txBody>
-          <a:bodyPr rtlCol="0" anchor="ctr"/>
-          <a:lstStyle/>
-          <a:p>
-            <a:pPr algn="ctr"/>
-          </a:p>
-        </p:txBody>
-      </p:sp>
-      <p:sp>
-        <p:nvSpPr>
-          <p:cNvPr id="20" name="Rounded Rectangle 19"/>
-          <p:cNvSpPr/>
-          <p:nvPr/>
-        </p:nvSpPr>
-        <p:spPr>
-          <a:xfrm>
-            <a:off x="6720840" y="3081528"/>
-            <a:ext cx="1234440" cy="566928"/>
-          </a:xfrm>
-          <a:prstGeom prst="roundRect">
-            <a:avLst>
-              <a:gd name="adj" fmla="val 18000"/>
+              <a:gd name="adj" fmla="val 16000"/>
             </a:avLst>
           </a:prstGeom>
           <a:solidFill>
@@ -7988,537 +8422,7 @@
       </p:sp>
       <p:sp>
         <p:nvSpPr>
-          <p:cNvPr id="21" name="TextBox 20"/>
-          <p:cNvSpPr txBox="1"/>
-          <p:nvPr/>
-        </p:nvSpPr>
-        <p:spPr>
-          <a:xfrm>
-            <a:off x="6784848" y="3081528"/>
-            <a:ext cx="1115568" cy="566928"/>
-          </a:xfrm>
-          <a:prstGeom prst="rect">
-            <a:avLst/>
-          </a:prstGeom>
-          <a:noFill/>
-        </p:spPr>
-        <p:txBody>
-          <a:bodyPr wrap="square" anchor="ctr" lIns="0" rIns="0" tIns="0" bIns="0">
-            <a:spAutoFit/>
-          </a:bodyPr>
-          <a:lstStyle/>
-          <a:p>
-            <a:pPr algn="ctr">
-              <a:lnSpc>
-                <a:spcPct val="100000"/>
-              </a:lnSpc>
-              <a:spcAft>
-                <a:spcPts val="600"/>
-              </a:spcAft>
-            </a:pPr>
-            <a:r>
-              <a:rPr sz="1350" b="1" i="0">
-                <a:solidFill>
-                  <a:srgbClr val="FFFFFF"/>
-                </a:solidFill>
-                <a:latin typeface="Noto Sans CJK SC"/>
-                <a:ea typeface="Noto Sans CJK SC"/>
-              </a:rPr>
-              <a:t>1/3~1/5</a:t>
-            </a:r>
-          </a:p>
-        </p:txBody>
-      </p:sp>
-      <p:sp>
-        <p:nvSpPr>
-          <p:cNvPr id="22" name="TextBox 21"/>
-          <p:cNvSpPr txBox="1"/>
-          <p:nvPr/>
-        </p:nvSpPr>
-        <p:spPr>
-          <a:xfrm>
-            <a:off x="8092440" y="3081528"/>
-            <a:ext cx="3474720" cy="566928"/>
-          </a:xfrm>
-          <a:prstGeom prst="rect">
-            <a:avLst/>
-          </a:prstGeom>
-          <a:noFill/>
-        </p:spPr>
-        <p:txBody>
-          <a:bodyPr wrap="square" anchor="ctr" lIns="0" rIns="0" tIns="0" bIns="0">
-            <a:spAutoFit/>
-          </a:bodyPr>
-          <a:lstStyle/>
-          <a:p>
-            <a:pPr algn="l">
-              <a:lnSpc>
-                <a:spcPct val="100000"/>
-              </a:lnSpc>
-              <a:spcAft>
-                <a:spcPts val="0"/>
-              </a:spcAft>
-            </a:pPr>
-            <a:r>
-              <a:rPr sz="1450" b="1" i="0">
-                <a:solidFill>
-                  <a:srgbClr val="FFFFFF"/>
-                </a:solidFill>
-                <a:latin typeface="Noto Sans CJK SC"/>
-                <a:ea typeface="Noto Sans CJK SC"/>
-              </a:rPr>
-              <a:t>价格</a:t>
-            </a:r>
-          </a:p>
-        </p:txBody>
-      </p:sp>
-      <p:sp>
-        <p:nvSpPr>
-          <p:cNvPr id="23" name="TextBox 22"/>
-          <p:cNvSpPr txBox="1"/>
-          <p:nvPr/>
-        </p:nvSpPr>
-        <p:spPr>
-          <a:xfrm>
-            <a:off x="6720840" y="3685032"/>
-            <a:ext cx="4892040" cy="566928"/>
-          </a:xfrm>
-          <a:prstGeom prst="rect">
-            <a:avLst/>
-          </a:prstGeom>
-          <a:noFill/>
-        </p:spPr>
-        <p:txBody>
-          <a:bodyPr wrap="square" anchor="t" lIns="0" rIns="0" tIns="0" bIns="0">
-            <a:spAutoFit/>
-          </a:bodyPr>
-          <a:lstStyle/>
-          <a:p>
-            <a:pPr algn="l">
-              <a:lnSpc>
-                <a:spcPct val="108000"/>
-              </a:lnSpc>
-              <a:spcAft>
-                <a:spcPts val="0"/>
-              </a:spcAft>
-            </a:pPr>
-            <a:r>
-              <a:rPr sz="1150" b="0" i="0">
-                <a:solidFill>
-                  <a:srgbClr val="B9C5D4"/>
-                </a:solidFill>
-                <a:latin typeface="Noto Sans CJK SC"/>
-                <a:ea typeface="Noto Sans CJK SC"/>
-              </a:rPr>
-              <a:t>培育钻仅为天然钻的 1/3 ~ 1/5：同样预算，克拉数翻倍</a:t>
-            </a:r>
-          </a:p>
-        </p:txBody>
-      </p:sp>
-      <p:sp>
-        <p:nvSpPr>
-          <p:cNvPr id="24" name="Rounded Rectangle 23"/>
-          <p:cNvSpPr/>
-          <p:nvPr/>
-        </p:nvSpPr>
-        <p:spPr>
-          <a:xfrm>
-            <a:off x="6720840" y="4379976"/>
-            <a:ext cx="4892040" cy="566928"/>
-          </a:xfrm>
-          <a:prstGeom prst="roundRect">
-            <a:avLst>
-              <a:gd name="adj" fmla="val 18000"/>
-            </a:avLst>
-          </a:prstGeom>
-          <a:solidFill>
-            <a:srgbClr val="1E3D5C"/>
-          </a:solidFill>
-          <a:ln>
-            <a:noFill/>
-          </a:ln>
-          <a:effectLst/>
-        </p:spPr>
-        <p:style>
-          <a:lnRef idx="1">
-            <a:schemeClr val="accent1"/>
-          </a:lnRef>
-          <a:fillRef idx="3">
-            <a:schemeClr val="accent1"/>
-          </a:fillRef>
-          <a:effectRef idx="2">
-            <a:schemeClr val="accent1"/>
-          </a:effectRef>
-          <a:fontRef idx="minor">
-            <a:schemeClr val="lt1"/>
-          </a:fontRef>
-        </p:style>
-        <p:txBody>
-          <a:bodyPr rtlCol="0" anchor="ctr"/>
-          <a:lstStyle/>
-          <a:p>
-            <a:pPr algn="ctr"/>
-          </a:p>
-        </p:txBody>
-      </p:sp>
-      <p:sp>
-        <p:nvSpPr>
-          <p:cNvPr id="25" name="Rounded Rectangle 24"/>
-          <p:cNvSpPr/>
-          <p:nvPr/>
-        </p:nvSpPr>
-        <p:spPr>
-          <a:xfrm>
-            <a:off x="6720840" y="4379976"/>
-            <a:ext cx="1234440" cy="566928"/>
-          </a:xfrm>
-          <a:prstGeom prst="roundRect">
-            <a:avLst>
-              <a:gd name="adj" fmla="val 18000"/>
-            </a:avLst>
-          </a:prstGeom>
-          <a:solidFill>
-            <a:srgbClr val="B03A2E"/>
-          </a:solidFill>
-          <a:ln>
-            <a:noFill/>
-          </a:ln>
-          <a:effectLst/>
-        </p:spPr>
-        <p:style>
-          <a:lnRef idx="1">
-            <a:schemeClr val="accent1"/>
-          </a:lnRef>
-          <a:fillRef idx="3">
-            <a:schemeClr val="accent1"/>
-          </a:fillRef>
-          <a:effectRef idx="2">
-            <a:schemeClr val="accent1"/>
-          </a:effectRef>
-          <a:fontRef idx="minor">
-            <a:schemeClr val="lt1"/>
-          </a:fontRef>
-        </p:style>
-        <p:txBody>
-          <a:bodyPr rtlCol="0" anchor="ctr"/>
-          <a:lstStyle/>
-          <a:p>
-            <a:pPr algn="ctr"/>
-          </a:p>
-        </p:txBody>
-      </p:sp>
-      <p:sp>
-        <p:nvSpPr>
-          <p:cNvPr id="26" name="TextBox 25"/>
-          <p:cNvSpPr txBox="1"/>
-          <p:nvPr/>
-        </p:nvSpPr>
-        <p:spPr>
-          <a:xfrm>
-            <a:off x="6784848" y="4379976"/>
-            <a:ext cx="1115568" cy="566928"/>
-          </a:xfrm>
-          <a:prstGeom prst="rect">
-            <a:avLst/>
-          </a:prstGeom>
-          <a:noFill/>
-        </p:spPr>
-        <p:txBody>
-          <a:bodyPr wrap="square" anchor="ctr" lIns="0" rIns="0" tIns="0" bIns="0">
-            <a:spAutoFit/>
-          </a:bodyPr>
-          <a:lstStyle/>
-          <a:p>
-            <a:pPr algn="ctr">
-              <a:lnSpc>
-                <a:spcPct val="100000"/>
-              </a:lnSpc>
-              <a:spcAft>
-                <a:spcPts val="600"/>
-              </a:spcAft>
-            </a:pPr>
-            <a:r>
-              <a:rPr sz="1350" b="1" i="0">
-                <a:solidFill>
-                  <a:srgbClr val="FFFFFF"/>
-                </a:solidFill>
-                <a:latin typeface="Noto Sans CJK SC"/>
-                <a:ea typeface="Noto Sans CJK SC"/>
-              </a:rPr>
-              <a:t>无上限</a:t>
-            </a:r>
-          </a:p>
-        </p:txBody>
-      </p:sp>
-      <p:sp>
-        <p:nvSpPr>
-          <p:cNvPr id="27" name="TextBox 26"/>
-          <p:cNvSpPr txBox="1"/>
-          <p:nvPr/>
-        </p:nvSpPr>
-        <p:spPr>
-          <a:xfrm>
-            <a:off x="8092440" y="4379976"/>
-            <a:ext cx="3474720" cy="566928"/>
-          </a:xfrm>
-          <a:prstGeom prst="rect">
-            <a:avLst/>
-          </a:prstGeom>
-          <a:noFill/>
-        </p:spPr>
-        <p:txBody>
-          <a:bodyPr wrap="square" anchor="ctr" lIns="0" rIns="0" tIns="0" bIns="0">
-            <a:spAutoFit/>
-          </a:bodyPr>
-          <a:lstStyle/>
-          <a:p>
-            <a:pPr algn="l">
-              <a:lnSpc>
-                <a:spcPct val="100000"/>
-              </a:lnSpc>
-              <a:spcAft>
-                <a:spcPts val="0"/>
-              </a:spcAft>
-            </a:pPr>
-            <a:r>
-              <a:rPr sz="1450" b="1" i="0">
-                <a:solidFill>
-                  <a:srgbClr val="FFFFFF"/>
-                </a:solidFill>
-                <a:latin typeface="Noto Sans CJK SC"/>
-                <a:ea typeface="Noto Sans CJK SC"/>
-              </a:rPr>
-              <a:t>供给能力</a:t>
-            </a:r>
-          </a:p>
-        </p:txBody>
-      </p:sp>
-      <p:sp>
-        <p:nvSpPr>
-          <p:cNvPr id="28" name="TextBox 27"/>
-          <p:cNvSpPr txBox="1"/>
-          <p:nvPr/>
-        </p:nvSpPr>
-        <p:spPr>
-          <a:xfrm>
-            <a:off x="6720840" y="4983480"/>
-            <a:ext cx="4892040" cy="566928"/>
-          </a:xfrm>
-          <a:prstGeom prst="rect">
-            <a:avLst/>
-          </a:prstGeom>
-          <a:noFill/>
-        </p:spPr>
-        <p:txBody>
-          <a:bodyPr wrap="square" anchor="t" lIns="0" rIns="0" tIns="0" bIns="0">
-            <a:spAutoFit/>
-          </a:bodyPr>
-          <a:lstStyle/>
-          <a:p>
-            <a:pPr algn="l">
-              <a:lnSpc>
-                <a:spcPct val="108000"/>
-              </a:lnSpc>
-              <a:spcAft>
-                <a:spcPts val="0"/>
-              </a:spcAft>
-            </a:pPr>
-            <a:r>
-              <a:rPr sz="1150" b="0" i="0">
-                <a:solidFill>
-                  <a:srgbClr val="B9C5D4"/>
-                </a:solidFill>
-                <a:latin typeface="Noto Sans CJK SC"/>
-                <a:ea typeface="Noto Sans CJK SC"/>
-              </a:rPr>
-              <a:t>天然钻依赖矿产开采、储量有限；培育钻可规模化量产、成本持续下降</a:t>
-            </a:r>
-          </a:p>
-        </p:txBody>
-      </p:sp>
-      <p:sp>
-        <p:nvSpPr>
-          <p:cNvPr id="29" name="Rounded Rectangle 28"/>
-          <p:cNvSpPr/>
-          <p:nvPr/>
-        </p:nvSpPr>
-        <p:spPr>
-          <a:xfrm>
-            <a:off x="868680" y="4069080"/>
-            <a:ext cx="4892040" cy="1600200"/>
-          </a:xfrm>
-          <a:prstGeom prst="roundRect">
-            <a:avLst>
-              <a:gd name="adj" fmla="val 10000"/>
-            </a:avLst>
-          </a:prstGeom>
-          <a:solidFill>
-            <a:srgbClr val="1E3D5C"/>
-          </a:solidFill>
-          <a:ln w="12700">
-            <a:solidFill>
-              <a:srgbClr val="C9A24B"/>
-            </a:solidFill>
-          </a:ln>
-          <a:effectLst/>
-        </p:spPr>
-        <p:style>
-          <a:lnRef idx="1">
-            <a:schemeClr val="accent1"/>
-          </a:lnRef>
-          <a:fillRef idx="3">
-            <a:schemeClr val="accent1"/>
-          </a:fillRef>
-          <a:effectRef idx="2">
-            <a:schemeClr val="accent1"/>
-          </a:effectRef>
-          <a:fontRef idx="minor">
-            <a:schemeClr val="lt1"/>
-          </a:fontRef>
-        </p:style>
-        <p:txBody>
-          <a:bodyPr rtlCol="0" anchor="ctr"/>
-          <a:lstStyle/>
-          <a:p>
-            <a:pPr algn="ctr"/>
-          </a:p>
-        </p:txBody>
-      </p:sp>
-      <p:sp>
-        <p:nvSpPr>
-          <p:cNvPr id="30" name="TextBox 29"/>
-          <p:cNvSpPr txBox="1"/>
-          <p:nvPr/>
-        </p:nvSpPr>
-        <p:spPr>
-          <a:xfrm>
-            <a:off x="1143000" y="4279392"/>
-            <a:ext cx="4389120" cy="457200"/>
-          </a:xfrm>
-          <a:prstGeom prst="rect">
-            <a:avLst/>
-          </a:prstGeom>
-          <a:noFill/>
-        </p:spPr>
-        <p:txBody>
-          <a:bodyPr wrap="square" anchor="t" lIns="0" rIns="0" tIns="0" bIns="0">
-            <a:spAutoFit/>
-          </a:bodyPr>
-          <a:lstStyle/>
-          <a:p>
-            <a:pPr algn="l">
-              <a:lnSpc>
-                <a:spcPct val="100000"/>
-              </a:lnSpc>
-              <a:spcAft>
-                <a:spcPts val="600"/>
-              </a:spcAft>
-            </a:pPr>
-            <a:r>
-              <a:rPr sz="1450" b="1" i="0">
-                <a:solidFill>
-                  <a:srgbClr val="C9A24B"/>
-                </a:solidFill>
-                <a:latin typeface="Noto Sans CJK SC"/>
-                <a:ea typeface="Noto Sans CJK SC"/>
-              </a:rPr>
-              <a:t>美国婚戒市场正在发生什么？</a:t>
-            </a:r>
-          </a:p>
-        </p:txBody>
-      </p:sp>
-      <p:sp>
-        <p:nvSpPr>
           <p:cNvPr id="31" name="TextBox 30"/>
-          <p:cNvSpPr txBox="1"/>
-          <p:nvPr/>
-        </p:nvSpPr>
-        <p:spPr>
-          <a:xfrm>
-            <a:off x="1143000" y="4736592"/>
-            <a:ext cx="4389120" cy="868680"/>
-          </a:xfrm>
-          <a:prstGeom prst="rect">
-            <a:avLst/>
-          </a:prstGeom>
-          <a:noFill/>
-        </p:spPr>
-        <p:txBody>
-          <a:bodyPr wrap="square" anchor="t" lIns="0" rIns="0" tIns="0" bIns="0">
-            <a:spAutoFit/>
-          </a:bodyPr>
-          <a:lstStyle/>
-          <a:p>
-            <a:pPr algn="l">
-              <a:lnSpc>
-                <a:spcPct val="115000"/>
-              </a:lnSpc>
-              <a:spcAft>
-                <a:spcPts val="600"/>
-              </a:spcAft>
-            </a:pPr>
-            <a:r>
-              <a:rPr sz="1250" b="0" i="0">
-                <a:solidFill>
-                  <a:srgbClr val="FFFFFF"/>
-                </a:solidFill>
-                <a:latin typeface="Noto Sans CJK SC"/>
-                <a:ea typeface="Noto Sans CJK SC"/>
-              </a:rPr>
-              <a:t>培育钻在美国订婚戒中的渗透率逐年快速提升，年轻一代把“更大克拉 + 更好价格 + 环保”当作新常识</a:t>
-            </a:r>
-          </a:p>
-        </p:txBody>
-      </p:sp>
-      <p:sp>
-        <p:nvSpPr>
-          <p:cNvPr id="32" name="Rounded Rectangle 31"/>
-          <p:cNvSpPr/>
-          <p:nvPr/>
-        </p:nvSpPr>
-        <p:spPr>
-          <a:xfrm>
-            <a:off x="868680" y="5870448"/>
-            <a:ext cx="10744200" cy="749808"/>
-          </a:xfrm>
-          <a:prstGeom prst="roundRect">
-            <a:avLst>
-              <a:gd name="adj" fmla="val 16000"/>
-            </a:avLst>
-          </a:prstGeom>
-          <a:solidFill>
-            <a:srgbClr val="C9A24B"/>
-          </a:solidFill>
-          <a:ln>
-            <a:noFill/>
-          </a:ln>
-          <a:effectLst/>
-        </p:spPr>
-        <p:style>
-          <a:lnRef idx="1">
-            <a:schemeClr val="accent1"/>
-          </a:lnRef>
-          <a:fillRef idx="3">
-            <a:schemeClr val="accent1"/>
-          </a:fillRef>
-          <a:effectRef idx="2">
-            <a:schemeClr val="accent1"/>
-          </a:effectRef>
-          <a:fontRef idx="minor">
-            <a:schemeClr val="lt1"/>
-          </a:fontRef>
-        </p:style>
-        <p:txBody>
-          <a:bodyPr rtlCol="0" anchor="ctr"/>
-          <a:lstStyle/>
-          <a:p>
-            <a:pPr algn="ctr"/>
-          </a:p>
-        </p:txBody>
-      </p:sp>
-      <p:sp>
-        <p:nvSpPr>
-          <p:cNvPr id="33" name="TextBox 32"/>
           <p:cNvSpPr txBox="1"/>
           <p:nvPr/>
         </p:nvSpPr>

</xml_diff>

<commit_message>
Strengthen finance credibility: add order-volume breakdown row and 4-5 year multi-site roadmap bridge
Co-authored-by: devlee <devlee@outlook.com>
</commit_message>
<xml_diff>
--- a/ppt/克拉先生_裂变项目总经理竞选PPT.pptx
+++ b/ppt/克拉先生_裂变项目总经理竞选PPT.pptx
@@ -6834,14 +6834,14 @@
               <a:t>目标：</a:t>
             </a:r>
             <a:r>
-              <a:rPr sz="1700" b="1" i="0">
+              <a:rPr sz="1600" b="1" i="0">
                 <a:solidFill>
                   <a:srgbClr val="FFFFFF"/>
                 </a:solidFill>
                 <a:latin typeface="Noto Sans CJK SC"/>
                 <a:ea typeface="Noto Sans CJK SC"/>
               </a:rPr>
-              <a:t>打造年收益 5,000 万美金量级的美国培育钻婚戒独立站。下有零库存保底，上有流量红利想象力。</a:t>
+              <a:t>第 1~3 年跑通单站模型，第 4~5 年复制多站点、多市场，冲击年收益 5,000 万美金量级。下有零库存保底，上有流量红利想象力。</a:t>
             </a:r>
           </a:p>
         </p:txBody>
@@ -16911,7 +16911,7 @@
                 <a:latin typeface="Noto Sans CJK SC"/>
                 <a:ea typeface="Noto Sans CJK SC"/>
               </a:rPr>
-              <a:t>总投入 160 万（3 年储备） · 目标利润率 15%~20%（下表为测算示例，口径可复核）</a:t>
+              <a:t>总投入 160 万（3 年储备） · 净利率 15%~20% · 客单价按 $2,000（约 1.4 万元）测算，示例口径可复核</a:t>
             </a:r>
           </a:p>
         </p:txBody>
@@ -17010,8 +17010,8 @@
         </p:nvSpPr>
         <p:spPr>
           <a:xfrm>
-            <a:off x="566928" y="1691640"/>
-            <a:ext cx="3017520" cy="566928"/>
+            <a:off x="566928" y="1572768"/>
+            <a:ext cx="3017520" cy="512064"/>
           </a:xfrm>
           <a:prstGeom prst="rect">
             <a:avLst/>
@@ -17056,8 +17056,8 @@
         </p:nvSpPr>
         <p:spPr>
           <a:xfrm>
-            <a:off x="704088" y="1691640"/>
-            <a:ext cx="2743200" cy="566928"/>
+            <a:off x="704088" y="1572768"/>
+            <a:ext cx="2743200" cy="512064"/>
           </a:xfrm>
           <a:prstGeom prst="rect">
             <a:avLst/>
@@ -17079,7 +17079,7 @@
               </a:spcAft>
             </a:pPr>
             <a:r>
-              <a:rPr sz="1350" b="1" i="0">
+              <a:rPr sz="1300" b="1" i="0">
                 <a:solidFill>
                   <a:srgbClr val="FFFFFF"/>
                 </a:solidFill>
@@ -17099,8 +17099,8 @@
         </p:nvSpPr>
         <p:spPr>
           <a:xfrm>
-            <a:off x="3584448" y="1691640"/>
-            <a:ext cx="2651760" cy="566928"/>
+            <a:off x="3584448" y="1572768"/>
+            <a:ext cx="2651760" cy="512064"/>
           </a:xfrm>
           <a:prstGeom prst="rect">
             <a:avLst/>
@@ -17145,8 +17145,8 @@
         </p:nvSpPr>
         <p:spPr>
           <a:xfrm>
-            <a:off x="3721608" y="1691640"/>
-            <a:ext cx="2377440" cy="566928"/>
+            <a:off x="3721608" y="1572768"/>
+            <a:ext cx="2377440" cy="512064"/>
           </a:xfrm>
           <a:prstGeom prst="rect">
             <a:avLst/>
@@ -17168,7 +17168,7 @@
               </a:spcAft>
             </a:pPr>
             <a:r>
-              <a:rPr sz="1350" b="1" i="0">
+              <a:rPr sz="1300" b="1" i="0">
                 <a:solidFill>
                   <a:srgbClr val="FFFFFF"/>
                 </a:solidFill>
@@ -17188,8 +17188,8 @@
         </p:nvSpPr>
         <p:spPr>
           <a:xfrm>
-            <a:off x="6236208" y="1691640"/>
-            <a:ext cx="2651760" cy="566928"/>
+            <a:off x="6236208" y="1572768"/>
+            <a:ext cx="2651760" cy="512064"/>
           </a:xfrm>
           <a:prstGeom prst="rect">
             <a:avLst/>
@@ -17234,8 +17234,8 @@
         </p:nvSpPr>
         <p:spPr>
           <a:xfrm>
-            <a:off x="6373368" y="1691640"/>
-            <a:ext cx="2377440" cy="566928"/>
+            <a:off x="6373368" y="1572768"/>
+            <a:ext cx="2377440" cy="512064"/>
           </a:xfrm>
           <a:prstGeom prst="rect">
             <a:avLst/>
@@ -17257,7 +17257,7 @@
               </a:spcAft>
             </a:pPr>
             <a:r>
-              <a:rPr sz="1350" b="1" i="0">
+              <a:rPr sz="1300" b="1" i="0">
                 <a:solidFill>
                   <a:srgbClr val="FFFFFF"/>
                 </a:solidFill>
@@ -17277,8 +17277,8 @@
         </p:nvSpPr>
         <p:spPr>
           <a:xfrm>
-            <a:off x="8887968" y="1691640"/>
-            <a:ext cx="2724912" cy="566928"/>
+            <a:off x="8887968" y="1572768"/>
+            <a:ext cx="2724912" cy="512064"/>
           </a:xfrm>
           <a:prstGeom prst="rect">
             <a:avLst/>
@@ -17323,8 +17323,8 @@
         </p:nvSpPr>
         <p:spPr>
           <a:xfrm>
-            <a:off x="9025128" y="1691640"/>
-            <a:ext cx="2450592" cy="566928"/>
+            <a:off x="9025128" y="1572768"/>
+            <a:ext cx="2450592" cy="512064"/>
           </a:xfrm>
           <a:prstGeom prst="rect">
             <a:avLst/>
@@ -17346,7 +17346,7 @@
               </a:spcAft>
             </a:pPr>
             <a:r>
-              <a:rPr sz="1350" b="1" i="0">
+              <a:rPr sz="1300" b="1" i="0">
                 <a:solidFill>
                   <a:srgbClr val="FFFFFF"/>
                 </a:solidFill>
@@ -17366,8 +17366,8 @@
         </p:nvSpPr>
         <p:spPr>
           <a:xfrm>
-            <a:off x="566928" y="2258568"/>
-            <a:ext cx="3017520" cy="566928"/>
+            <a:off x="566928" y="2084832"/>
+            <a:ext cx="3017520" cy="512064"/>
           </a:xfrm>
           <a:prstGeom prst="rect">
             <a:avLst/>
@@ -17412,8 +17412,8 @@
         </p:nvSpPr>
         <p:spPr>
           <a:xfrm>
-            <a:off x="704088" y="2258568"/>
-            <a:ext cx="2743200" cy="566928"/>
+            <a:off x="704088" y="2084832"/>
+            <a:ext cx="2743200" cy="512064"/>
           </a:xfrm>
           <a:prstGeom prst="rect">
             <a:avLst/>
@@ -17435,7 +17435,7 @@
               </a:spcAft>
             </a:pPr>
             <a:r>
-              <a:rPr sz="1350" b="1" i="0">
+              <a:rPr sz="1300" b="1" i="0">
                 <a:solidFill>
                   <a:srgbClr val="222A33"/>
                 </a:solidFill>
@@ -17455,8 +17455,8 @@
         </p:nvSpPr>
         <p:spPr>
           <a:xfrm>
-            <a:off x="3584448" y="2258568"/>
-            <a:ext cx="2651760" cy="566928"/>
+            <a:off x="3584448" y="2084832"/>
+            <a:ext cx="2651760" cy="512064"/>
           </a:xfrm>
           <a:prstGeom prst="rect">
             <a:avLst/>
@@ -17501,8 +17501,8 @@
         </p:nvSpPr>
         <p:spPr>
           <a:xfrm>
-            <a:off x="3721608" y="2258568"/>
-            <a:ext cx="2377440" cy="566928"/>
+            <a:off x="3721608" y="2084832"/>
+            <a:ext cx="2377440" cy="512064"/>
           </a:xfrm>
           <a:prstGeom prst="rect">
             <a:avLst/>
@@ -17524,7 +17524,7 @@
               </a:spcAft>
             </a:pPr>
             <a:r>
-              <a:rPr sz="1350" b="0" i="0">
+              <a:rPr sz="1300" b="0" i="0">
                 <a:solidFill>
                   <a:srgbClr val="222A33"/>
                 </a:solidFill>
@@ -17544,8 +17544,8 @@
         </p:nvSpPr>
         <p:spPr>
           <a:xfrm>
-            <a:off x="6236208" y="2258568"/>
-            <a:ext cx="2651760" cy="566928"/>
+            <a:off x="6236208" y="2084832"/>
+            <a:ext cx="2651760" cy="512064"/>
           </a:xfrm>
           <a:prstGeom prst="rect">
             <a:avLst/>
@@ -17590,8 +17590,8 @@
         </p:nvSpPr>
         <p:spPr>
           <a:xfrm>
-            <a:off x="6373368" y="2258568"/>
-            <a:ext cx="2377440" cy="566928"/>
+            <a:off x="6373368" y="2084832"/>
+            <a:ext cx="2377440" cy="512064"/>
           </a:xfrm>
           <a:prstGeom prst="rect">
             <a:avLst/>
@@ -17613,7 +17613,7 @@
               </a:spcAft>
             </a:pPr>
             <a:r>
-              <a:rPr sz="1350" b="0" i="0">
+              <a:rPr sz="1300" b="0" i="0">
                 <a:solidFill>
                   <a:srgbClr val="222A33"/>
                 </a:solidFill>
@@ -17633,8 +17633,8 @@
         </p:nvSpPr>
         <p:spPr>
           <a:xfrm>
-            <a:off x="8887968" y="2258568"/>
-            <a:ext cx="2724912" cy="566928"/>
+            <a:off x="8887968" y="2084832"/>
+            <a:ext cx="2724912" cy="512064"/>
           </a:xfrm>
           <a:prstGeom prst="rect">
             <a:avLst/>
@@ -17679,8 +17679,8 @@
         </p:nvSpPr>
         <p:spPr>
           <a:xfrm>
-            <a:off x="9025128" y="2258568"/>
-            <a:ext cx="2450592" cy="566928"/>
+            <a:off x="9025128" y="2084832"/>
+            <a:ext cx="2450592" cy="512064"/>
           </a:xfrm>
           <a:prstGeom prst="rect">
             <a:avLst/>
@@ -17702,7 +17702,7 @@
               </a:spcAft>
             </a:pPr>
             <a:r>
-              <a:rPr sz="1350" b="0" i="0">
+              <a:rPr sz="1300" b="0" i="0">
                 <a:solidFill>
                   <a:srgbClr val="222A33"/>
                 </a:solidFill>
@@ -17722,8 +17722,8 @@
         </p:nvSpPr>
         <p:spPr>
           <a:xfrm>
-            <a:off x="566928" y="2825496"/>
-            <a:ext cx="3017520" cy="566928"/>
+            <a:off x="566928" y="2596896"/>
+            <a:ext cx="3017520" cy="512064"/>
           </a:xfrm>
           <a:prstGeom prst="rect">
             <a:avLst/>
@@ -17768,8 +17768,8 @@
         </p:nvSpPr>
         <p:spPr>
           <a:xfrm>
-            <a:off x="704088" y="2825496"/>
-            <a:ext cx="2743200" cy="566928"/>
+            <a:off x="704088" y="2596896"/>
+            <a:ext cx="2743200" cy="512064"/>
           </a:xfrm>
           <a:prstGeom prst="rect">
             <a:avLst/>
@@ -17791,14 +17791,14 @@
               </a:spcAft>
             </a:pPr>
             <a:r>
-              <a:rPr sz="1350" b="1" i="0">
+              <a:rPr sz="1300" b="1" i="0">
                 <a:solidFill>
                   <a:srgbClr val="222A33"/>
                 </a:solidFill>
                 <a:latin typeface="Noto Sans CJK SC"/>
                 <a:ea typeface="Noto Sans CJK SC"/>
               </a:rPr>
-              <a:t>广告及营销投放（40%）</a:t>
+              <a:t>订单量（月均）</a:t>
             </a:r>
           </a:p>
         </p:txBody>
@@ -17811,8 +17811,8 @@
         </p:nvSpPr>
         <p:spPr>
           <a:xfrm>
-            <a:off x="3584448" y="2825496"/>
-            <a:ext cx="2651760" cy="566928"/>
+            <a:off x="3584448" y="2596896"/>
+            <a:ext cx="2651760" cy="512064"/>
           </a:xfrm>
           <a:prstGeom prst="rect">
             <a:avLst/>
@@ -17857,8 +17857,8 @@
         </p:nvSpPr>
         <p:spPr>
           <a:xfrm>
-            <a:off x="3721608" y="2825496"/>
-            <a:ext cx="2377440" cy="566928"/>
+            <a:off x="3721608" y="2596896"/>
+            <a:ext cx="2377440" cy="512064"/>
           </a:xfrm>
           <a:prstGeom prst="rect">
             <a:avLst/>
@@ -17880,14 +17880,14 @@
               </a:spcAft>
             </a:pPr>
             <a:r>
-              <a:rPr sz="1350" b="0" i="0">
+              <a:rPr sz="1300" b="0" i="0">
                 <a:solidFill>
                   <a:srgbClr val="222A33"/>
                 </a:solidFill>
                 <a:latin typeface="Noto Sans CJK SC"/>
                 <a:ea typeface="Noto Sans CJK SC"/>
               </a:rPr>
-              <a:t>200</a:t>
+              <a:t>约 360 单（月均 30）</a:t>
             </a:r>
           </a:p>
         </p:txBody>
@@ -17900,8 +17900,8 @@
         </p:nvSpPr>
         <p:spPr>
           <a:xfrm>
-            <a:off x="6236208" y="2825496"/>
-            <a:ext cx="2651760" cy="566928"/>
+            <a:off x="6236208" y="2596896"/>
+            <a:ext cx="2651760" cy="512064"/>
           </a:xfrm>
           <a:prstGeom prst="rect">
             <a:avLst/>
@@ -17946,8 +17946,8 @@
         </p:nvSpPr>
         <p:spPr>
           <a:xfrm>
-            <a:off x="6373368" y="2825496"/>
-            <a:ext cx="2377440" cy="566928"/>
+            <a:off x="6373368" y="2596896"/>
+            <a:ext cx="2377440" cy="512064"/>
           </a:xfrm>
           <a:prstGeom prst="rect">
             <a:avLst/>
@@ -17969,14 +17969,14 @@
               </a:spcAft>
             </a:pPr>
             <a:r>
-              <a:rPr sz="1350" b="0" i="0">
+              <a:rPr sz="1300" b="0" i="0">
                 <a:solidFill>
                   <a:srgbClr val="222A33"/>
                 </a:solidFill>
                 <a:latin typeface="Noto Sans CJK SC"/>
                 <a:ea typeface="Noto Sans CJK SC"/>
               </a:rPr>
-              <a:t>600</a:t>
+              <a:t>约 1,070 单（月均 90）</a:t>
             </a:r>
           </a:p>
         </p:txBody>
@@ -17989,8 +17989,8 @@
         </p:nvSpPr>
         <p:spPr>
           <a:xfrm>
-            <a:off x="8887968" y="2825496"/>
-            <a:ext cx="2724912" cy="566928"/>
+            <a:off x="8887968" y="2596896"/>
+            <a:ext cx="2724912" cy="512064"/>
           </a:xfrm>
           <a:prstGeom prst="rect">
             <a:avLst/>
@@ -18035,8 +18035,8 @@
         </p:nvSpPr>
         <p:spPr>
           <a:xfrm>
-            <a:off x="9025128" y="2825496"/>
-            <a:ext cx="2450592" cy="566928"/>
+            <a:off x="9025128" y="2596896"/>
+            <a:ext cx="2450592" cy="512064"/>
           </a:xfrm>
           <a:prstGeom prst="rect">
             <a:avLst/>
@@ -18058,14 +18058,14 @@
               </a:spcAft>
             </a:pPr>
             <a:r>
-              <a:rPr sz="1350" b="0" i="0">
+              <a:rPr sz="1300" b="0" i="0">
                 <a:solidFill>
                   <a:srgbClr val="222A33"/>
                 </a:solidFill>
                 <a:latin typeface="Noto Sans CJK SC"/>
                 <a:ea typeface="Noto Sans CJK SC"/>
               </a:rPr>
-              <a:t>1,440</a:t>
+              <a:t>约 2,570 单（月均 215）</a:t>
             </a:r>
           </a:p>
         </p:txBody>
@@ -18078,8 +18078,8 @@
         </p:nvSpPr>
         <p:spPr>
           <a:xfrm>
-            <a:off x="566928" y="3392424"/>
-            <a:ext cx="3017520" cy="566928"/>
+            <a:off x="566928" y="3108960"/>
+            <a:ext cx="3017520" cy="512064"/>
           </a:xfrm>
           <a:prstGeom prst="rect">
             <a:avLst/>
@@ -18124,8 +18124,8 @@
         </p:nvSpPr>
         <p:spPr>
           <a:xfrm>
-            <a:off x="704088" y="3392424"/>
-            <a:ext cx="2743200" cy="566928"/>
+            <a:off x="704088" y="3108960"/>
+            <a:ext cx="2743200" cy="512064"/>
           </a:xfrm>
           <a:prstGeom prst="rect">
             <a:avLst/>
@@ -18147,14 +18147,14 @@
               </a:spcAft>
             </a:pPr>
             <a:r>
-              <a:rPr sz="1350" b="1" i="0">
+              <a:rPr sz="1300" b="1" i="0">
                 <a:solidFill>
                   <a:srgbClr val="222A33"/>
                 </a:solidFill>
                 <a:latin typeface="Noto Sans CJK SC"/>
                 <a:ea typeface="Noto Sans CJK SC"/>
               </a:rPr>
-              <a:t>货品及履约成本（30%）</a:t>
+              <a:t>广告及营销投放（40%）</a:t>
             </a:r>
           </a:p>
         </p:txBody>
@@ -18167,8 +18167,8 @@
         </p:nvSpPr>
         <p:spPr>
           <a:xfrm>
-            <a:off x="3584448" y="3392424"/>
-            <a:ext cx="2651760" cy="566928"/>
+            <a:off x="3584448" y="3108960"/>
+            <a:ext cx="2651760" cy="512064"/>
           </a:xfrm>
           <a:prstGeom prst="rect">
             <a:avLst/>
@@ -18213,8 +18213,8 @@
         </p:nvSpPr>
         <p:spPr>
           <a:xfrm>
-            <a:off x="3721608" y="3392424"/>
-            <a:ext cx="2377440" cy="566928"/>
+            <a:off x="3721608" y="3108960"/>
+            <a:ext cx="2377440" cy="512064"/>
           </a:xfrm>
           <a:prstGeom prst="rect">
             <a:avLst/>
@@ -18236,14 +18236,14 @@
               </a:spcAft>
             </a:pPr>
             <a:r>
-              <a:rPr sz="1350" b="0" i="0">
+              <a:rPr sz="1300" b="0" i="0">
                 <a:solidFill>
                   <a:srgbClr val="222A33"/>
                 </a:solidFill>
                 <a:latin typeface="Noto Sans CJK SC"/>
                 <a:ea typeface="Noto Sans CJK SC"/>
               </a:rPr>
-              <a:t>150</a:t>
+              <a:t>200</a:t>
             </a:r>
           </a:p>
         </p:txBody>
@@ -18256,8 +18256,8 @@
         </p:nvSpPr>
         <p:spPr>
           <a:xfrm>
-            <a:off x="6236208" y="3392424"/>
-            <a:ext cx="2651760" cy="566928"/>
+            <a:off x="6236208" y="3108960"/>
+            <a:ext cx="2651760" cy="512064"/>
           </a:xfrm>
           <a:prstGeom prst="rect">
             <a:avLst/>
@@ -18302,8 +18302,8 @@
         </p:nvSpPr>
         <p:spPr>
           <a:xfrm>
-            <a:off x="6373368" y="3392424"/>
-            <a:ext cx="2377440" cy="566928"/>
+            <a:off x="6373368" y="3108960"/>
+            <a:ext cx="2377440" cy="512064"/>
           </a:xfrm>
           <a:prstGeom prst="rect">
             <a:avLst/>
@@ -18325,14 +18325,14 @@
               </a:spcAft>
             </a:pPr>
             <a:r>
-              <a:rPr sz="1350" b="0" i="0">
+              <a:rPr sz="1300" b="0" i="0">
                 <a:solidFill>
                   <a:srgbClr val="222A33"/>
                 </a:solidFill>
                 <a:latin typeface="Noto Sans CJK SC"/>
                 <a:ea typeface="Noto Sans CJK SC"/>
               </a:rPr>
-              <a:t>450</a:t>
+              <a:t>600</a:t>
             </a:r>
           </a:p>
         </p:txBody>
@@ -18345,8 +18345,8 @@
         </p:nvSpPr>
         <p:spPr>
           <a:xfrm>
-            <a:off x="8887968" y="3392424"/>
-            <a:ext cx="2724912" cy="566928"/>
+            <a:off x="8887968" y="3108960"/>
+            <a:ext cx="2724912" cy="512064"/>
           </a:xfrm>
           <a:prstGeom prst="rect">
             <a:avLst/>
@@ -18391,8 +18391,8 @@
         </p:nvSpPr>
         <p:spPr>
           <a:xfrm>
-            <a:off x="9025128" y="3392424"/>
-            <a:ext cx="2450592" cy="566928"/>
+            <a:off x="9025128" y="3108960"/>
+            <a:ext cx="2450592" cy="512064"/>
           </a:xfrm>
           <a:prstGeom prst="rect">
             <a:avLst/>
@@ -18414,14 +18414,14 @@
               </a:spcAft>
             </a:pPr>
             <a:r>
-              <a:rPr sz="1350" b="0" i="0">
+              <a:rPr sz="1300" b="0" i="0">
                 <a:solidFill>
                   <a:srgbClr val="222A33"/>
                 </a:solidFill>
                 <a:latin typeface="Noto Sans CJK SC"/>
                 <a:ea typeface="Noto Sans CJK SC"/>
               </a:rPr>
-              <a:t>1,080</a:t>
+              <a:t>1,440</a:t>
             </a:r>
           </a:p>
         </p:txBody>
@@ -18434,8 +18434,8 @@
         </p:nvSpPr>
         <p:spPr>
           <a:xfrm>
-            <a:off x="566928" y="3959352"/>
-            <a:ext cx="3017520" cy="566928"/>
+            <a:off x="566928" y="3621024"/>
+            <a:ext cx="3017520" cy="512064"/>
           </a:xfrm>
           <a:prstGeom prst="rect">
             <a:avLst/>
@@ -18480,8 +18480,8 @@
         </p:nvSpPr>
         <p:spPr>
           <a:xfrm>
-            <a:off x="704088" y="3959352"/>
-            <a:ext cx="2743200" cy="566928"/>
+            <a:off x="704088" y="3621024"/>
+            <a:ext cx="2743200" cy="512064"/>
           </a:xfrm>
           <a:prstGeom prst="rect">
             <a:avLst/>
@@ -18503,14 +18503,14 @@
               </a:spcAft>
             </a:pPr>
             <a:r>
-              <a:rPr sz="1350" b="1" i="0">
+              <a:rPr sz="1300" b="1" i="0">
                 <a:solidFill>
                   <a:srgbClr val="222A33"/>
                 </a:solidFill>
                 <a:latin typeface="Noto Sans CJK SC"/>
                 <a:ea typeface="Noto Sans CJK SC"/>
               </a:rPr>
-              <a:t>团队及运营费用（8%）</a:t>
+              <a:t>货品及履约成本（30%）</a:t>
             </a:r>
           </a:p>
         </p:txBody>
@@ -18523,8 +18523,8 @@
         </p:nvSpPr>
         <p:spPr>
           <a:xfrm>
-            <a:off x="3584448" y="3959352"/>
-            <a:ext cx="2651760" cy="566928"/>
+            <a:off x="3584448" y="3621024"/>
+            <a:ext cx="2651760" cy="512064"/>
           </a:xfrm>
           <a:prstGeom prst="rect">
             <a:avLst/>
@@ -18569,8 +18569,8 @@
         </p:nvSpPr>
         <p:spPr>
           <a:xfrm>
-            <a:off x="3721608" y="3959352"/>
-            <a:ext cx="2377440" cy="566928"/>
+            <a:off x="3721608" y="3621024"/>
+            <a:ext cx="2377440" cy="512064"/>
           </a:xfrm>
           <a:prstGeom prst="rect">
             <a:avLst/>
@@ -18592,14 +18592,14 @@
               </a:spcAft>
             </a:pPr>
             <a:r>
-              <a:rPr sz="1350" b="0" i="0">
+              <a:rPr sz="1300" b="0" i="0">
                 <a:solidFill>
                   <a:srgbClr val="222A33"/>
                 </a:solidFill>
                 <a:latin typeface="Noto Sans CJK SC"/>
                 <a:ea typeface="Noto Sans CJK SC"/>
               </a:rPr>
-              <a:t>40</a:t>
+              <a:t>150</a:t>
             </a:r>
           </a:p>
         </p:txBody>
@@ -18612,8 +18612,8 @@
         </p:nvSpPr>
         <p:spPr>
           <a:xfrm>
-            <a:off x="6236208" y="3959352"/>
-            <a:ext cx="2651760" cy="566928"/>
+            <a:off x="6236208" y="3621024"/>
+            <a:ext cx="2651760" cy="512064"/>
           </a:xfrm>
           <a:prstGeom prst="rect">
             <a:avLst/>
@@ -18658,8 +18658,8 @@
         </p:nvSpPr>
         <p:spPr>
           <a:xfrm>
-            <a:off x="6373368" y="3959352"/>
-            <a:ext cx="2377440" cy="566928"/>
+            <a:off x="6373368" y="3621024"/>
+            <a:ext cx="2377440" cy="512064"/>
           </a:xfrm>
           <a:prstGeom prst="rect">
             <a:avLst/>
@@ -18681,14 +18681,14 @@
               </a:spcAft>
             </a:pPr>
             <a:r>
-              <a:rPr sz="1350" b="0" i="0">
+              <a:rPr sz="1300" b="0" i="0">
                 <a:solidFill>
                   <a:srgbClr val="222A33"/>
                 </a:solidFill>
                 <a:latin typeface="Noto Sans CJK SC"/>
                 <a:ea typeface="Noto Sans CJK SC"/>
               </a:rPr>
-              <a:t>120</a:t>
+              <a:t>450</a:t>
             </a:r>
           </a:p>
         </p:txBody>
@@ -18701,8 +18701,8 @@
         </p:nvSpPr>
         <p:spPr>
           <a:xfrm>
-            <a:off x="8887968" y="3959352"/>
-            <a:ext cx="2724912" cy="566928"/>
+            <a:off x="8887968" y="3621024"/>
+            <a:ext cx="2724912" cy="512064"/>
           </a:xfrm>
           <a:prstGeom prst="rect">
             <a:avLst/>
@@ -18747,8 +18747,8 @@
         </p:nvSpPr>
         <p:spPr>
           <a:xfrm>
-            <a:off x="9025128" y="3959352"/>
-            <a:ext cx="2450592" cy="566928"/>
+            <a:off x="9025128" y="3621024"/>
+            <a:ext cx="2450592" cy="512064"/>
           </a:xfrm>
           <a:prstGeom prst="rect">
             <a:avLst/>
@@ -18770,14 +18770,14 @@
               </a:spcAft>
             </a:pPr>
             <a:r>
-              <a:rPr sz="1350" b="0" i="0">
+              <a:rPr sz="1300" b="0" i="0">
                 <a:solidFill>
                   <a:srgbClr val="222A33"/>
                 </a:solidFill>
                 <a:latin typeface="Noto Sans CJK SC"/>
                 <a:ea typeface="Noto Sans CJK SC"/>
               </a:rPr>
-              <a:t>288</a:t>
+              <a:t>1,080</a:t>
             </a:r>
           </a:p>
         </p:txBody>
@@ -18790,8 +18790,364 @@
         </p:nvSpPr>
         <p:spPr>
           <a:xfrm>
-            <a:off x="566928" y="4526280"/>
-            <a:ext cx="3017520" cy="566928"/>
+            <a:off x="566928" y="4133088"/>
+            <a:ext cx="3017520" cy="512064"/>
+          </a:xfrm>
+          <a:prstGeom prst="rect">
+            <a:avLst/>
+          </a:prstGeom>
+          <a:solidFill>
+            <a:srgbClr val="FFFFFF"/>
+          </a:solidFill>
+          <a:ln w="9525">
+            <a:solidFill>
+              <a:srgbClr val="D9D4C8"/>
+            </a:solidFill>
+          </a:ln>
+          <a:effectLst/>
+        </p:spPr>
+        <p:style>
+          <a:lnRef idx="1">
+            <a:schemeClr val="accent1"/>
+          </a:lnRef>
+          <a:fillRef idx="3">
+            <a:schemeClr val="accent1"/>
+          </a:fillRef>
+          <a:effectRef idx="2">
+            <a:schemeClr val="accent1"/>
+          </a:effectRef>
+          <a:fontRef idx="minor">
+            <a:schemeClr val="lt1"/>
+          </a:fontRef>
+        </p:style>
+        <p:txBody>
+          <a:bodyPr rtlCol="0" anchor="ctr"/>
+          <a:lstStyle/>
+          <a:p>
+            <a:pPr algn="ctr"/>
+          </a:p>
+        </p:txBody>
+      </p:sp>
+      <p:sp>
+        <p:nvSpPr>
+          <p:cNvPr id="50" name="TextBox 49"/>
+          <p:cNvSpPr txBox="1"/>
+          <p:nvPr/>
+        </p:nvSpPr>
+        <p:spPr>
+          <a:xfrm>
+            <a:off x="704088" y="4133088"/>
+            <a:ext cx="2743200" cy="512064"/>
+          </a:xfrm>
+          <a:prstGeom prst="rect">
+            <a:avLst/>
+          </a:prstGeom>
+          <a:noFill/>
+        </p:spPr>
+        <p:txBody>
+          <a:bodyPr wrap="square" anchor="ctr" lIns="0" rIns="0" tIns="0" bIns="0">
+            <a:spAutoFit/>
+          </a:bodyPr>
+          <a:lstStyle/>
+          <a:p>
+            <a:pPr algn="l">
+              <a:lnSpc>
+                <a:spcPct val="100000"/>
+              </a:lnSpc>
+              <a:spcAft>
+                <a:spcPts val="0"/>
+              </a:spcAft>
+            </a:pPr>
+            <a:r>
+              <a:rPr sz="1300" b="1" i="0">
+                <a:solidFill>
+                  <a:srgbClr val="222A33"/>
+                </a:solidFill>
+                <a:latin typeface="Noto Sans CJK SC"/>
+                <a:ea typeface="Noto Sans CJK SC"/>
+              </a:rPr>
+              <a:t>团队及运营费用（8%）</a:t>
+            </a:r>
+          </a:p>
+        </p:txBody>
+      </p:sp>
+      <p:sp>
+        <p:nvSpPr>
+          <p:cNvPr id="51" name="Rectangle 50"/>
+          <p:cNvSpPr/>
+          <p:nvPr/>
+        </p:nvSpPr>
+        <p:spPr>
+          <a:xfrm>
+            <a:off x="3584448" y="4133088"/>
+            <a:ext cx="2651760" cy="512064"/>
+          </a:xfrm>
+          <a:prstGeom prst="rect">
+            <a:avLst/>
+          </a:prstGeom>
+          <a:solidFill>
+            <a:srgbClr val="FFFFFF"/>
+          </a:solidFill>
+          <a:ln w="9525">
+            <a:solidFill>
+              <a:srgbClr val="D9D4C8"/>
+            </a:solidFill>
+          </a:ln>
+          <a:effectLst/>
+        </p:spPr>
+        <p:style>
+          <a:lnRef idx="1">
+            <a:schemeClr val="accent1"/>
+          </a:lnRef>
+          <a:fillRef idx="3">
+            <a:schemeClr val="accent1"/>
+          </a:fillRef>
+          <a:effectRef idx="2">
+            <a:schemeClr val="accent1"/>
+          </a:effectRef>
+          <a:fontRef idx="minor">
+            <a:schemeClr val="lt1"/>
+          </a:fontRef>
+        </p:style>
+        <p:txBody>
+          <a:bodyPr rtlCol="0" anchor="ctr"/>
+          <a:lstStyle/>
+          <a:p>
+            <a:pPr algn="ctr"/>
+          </a:p>
+        </p:txBody>
+      </p:sp>
+      <p:sp>
+        <p:nvSpPr>
+          <p:cNvPr id="52" name="TextBox 51"/>
+          <p:cNvSpPr txBox="1"/>
+          <p:nvPr/>
+        </p:nvSpPr>
+        <p:spPr>
+          <a:xfrm>
+            <a:off x="3721608" y="4133088"/>
+            <a:ext cx="2377440" cy="512064"/>
+          </a:xfrm>
+          <a:prstGeom prst="rect">
+            <a:avLst/>
+          </a:prstGeom>
+          <a:noFill/>
+        </p:spPr>
+        <p:txBody>
+          <a:bodyPr wrap="square" anchor="ctr" lIns="0" rIns="0" tIns="0" bIns="0">
+            <a:spAutoFit/>
+          </a:bodyPr>
+          <a:lstStyle/>
+          <a:p>
+            <a:pPr algn="ctr">
+              <a:lnSpc>
+                <a:spcPct val="100000"/>
+              </a:lnSpc>
+              <a:spcAft>
+                <a:spcPts val="0"/>
+              </a:spcAft>
+            </a:pPr>
+            <a:r>
+              <a:rPr sz="1300" b="0" i="0">
+                <a:solidFill>
+                  <a:srgbClr val="222A33"/>
+                </a:solidFill>
+                <a:latin typeface="Noto Sans CJK SC"/>
+                <a:ea typeface="Noto Sans CJK SC"/>
+              </a:rPr>
+              <a:t>40</a:t>
+            </a:r>
+          </a:p>
+        </p:txBody>
+      </p:sp>
+      <p:sp>
+        <p:nvSpPr>
+          <p:cNvPr id="53" name="Rectangle 52"/>
+          <p:cNvSpPr/>
+          <p:nvPr/>
+        </p:nvSpPr>
+        <p:spPr>
+          <a:xfrm>
+            <a:off x="6236208" y="4133088"/>
+            <a:ext cx="2651760" cy="512064"/>
+          </a:xfrm>
+          <a:prstGeom prst="rect">
+            <a:avLst/>
+          </a:prstGeom>
+          <a:solidFill>
+            <a:srgbClr val="FFFFFF"/>
+          </a:solidFill>
+          <a:ln w="9525">
+            <a:solidFill>
+              <a:srgbClr val="D9D4C8"/>
+            </a:solidFill>
+          </a:ln>
+          <a:effectLst/>
+        </p:spPr>
+        <p:style>
+          <a:lnRef idx="1">
+            <a:schemeClr val="accent1"/>
+          </a:lnRef>
+          <a:fillRef idx="3">
+            <a:schemeClr val="accent1"/>
+          </a:fillRef>
+          <a:effectRef idx="2">
+            <a:schemeClr val="accent1"/>
+          </a:effectRef>
+          <a:fontRef idx="minor">
+            <a:schemeClr val="lt1"/>
+          </a:fontRef>
+        </p:style>
+        <p:txBody>
+          <a:bodyPr rtlCol="0" anchor="ctr"/>
+          <a:lstStyle/>
+          <a:p>
+            <a:pPr algn="ctr"/>
+          </a:p>
+        </p:txBody>
+      </p:sp>
+      <p:sp>
+        <p:nvSpPr>
+          <p:cNvPr id="54" name="TextBox 53"/>
+          <p:cNvSpPr txBox="1"/>
+          <p:nvPr/>
+        </p:nvSpPr>
+        <p:spPr>
+          <a:xfrm>
+            <a:off x="6373368" y="4133088"/>
+            <a:ext cx="2377440" cy="512064"/>
+          </a:xfrm>
+          <a:prstGeom prst="rect">
+            <a:avLst/>
+          </a:prstGeom>
+          <a:noFill/>
+        </p:spPr>
+        <p:txBody>
+          <a:bodyPr wrap="square" anchor="ctr" lIns="0" rIns="0" tIns="0" bIns="0">
+            <a:spAutoFit/>
+          </a:bodyPr>
+          <a:lstStyle/>
+          <a:p>
+            <a:pPr algn="ctr">
+              <a:lnSpc>
+                <a:spcPct val="100000"/>
+              </a:lnSpc>
+              <a:spcAft>
+                <a:spcPts val="0"/>
+              </a:spcAft>
+            </a:pPr>
+            <a:r>
+              <a:rPr sz="1300" b="0" i="0">
+                <a:solidFill>
+                  <a:srgbClr val="222A33"/>
+                </a:solidFill>
+                <a:latin typeface="Noto Sans CJK SC"/>
+                <a:ea typeface="Noto Sans CJK SC"/>
+              </a:rPr>
+              <a:t>120</a:t>
+            </a:r>
+          </a:p>
+        </p:txBody>
+      </p:sp>
+      <p:sp>
+        <p:nvSpPr>
+          <p:cNvPr id="55" name="Rectangle 54"/>
+          <p:cNvSpPr/>
+          <p:nvPr/>
+        </p:nvSpPr>
+        <p:spPr>
+          <a:xfrm>
+            <a:off x="8887968" y="4133088"/>
+            <a:ext cx="2724912" cy="512064"/>
+          </a:xfrm>
+          <a:prstGeom prst="rect">
+            <a:avLst/>
+          </a:prstGeom>
+          <a:solidFill>
+            <a:srgbClr val="FFFFFF"/>
+          </a:solidFill>
+          <a:ln w="9525">
+            <a:solidFill>
+              <a:srgbClr val="D9D4C8"/>
+            </a:solidFill>
+          </a:ln>
+          <a:effectLst/>
+        </p:spPr>
+        <p:style>
+          <a:lnRef idx="1">
+            <a:schemeClr val="accent1"/>
+          </a:lnRef>
+          <a:fillRef idx="3">
+            <a:schemeClr val="accent1"/>
+          </a:fillRef>
+          <a:effectRef idx="2">
+            <a:schemeClr val="accent1"/>
+          </a:effectRef>
+          <a:fontRef idx="minor">
+            <a:schemeClr val="lt1"/>
+          </a:fontRef>
+        </p:style>
+        <p:txBody>
+          <a:bodyPr rtlCol="0" anchor="ctr"/>
+          <a:lstStyle/>
+          <a:p>
+            <a:pPr algn="ctr"/>
+          </a:p>
+        </p:txBody>
+      </p:sp>
+      <p:sp>
+        <p:nvSpPr>
+          <p:cNvPr id="56" name="TextBox 55"/>
+          <p:cNvSpPr txBox="1"/>
+          <p:nvPr/>
+        </p:nvSpPr>
+        <p:spPr>
+          <a:xfrm>
+            <a:off x="9025128" y="4133088"/>
+            <a:ext cx="2450592" cy="512064"/>
+          </a:xfrm>
+          <a:prstGeom prst="rect">
+            <a:avLst/>
+          </a:prstGeom>
+          <a:noFill/>
+        </p:spPr>
+        <p:txBody>
+          <a:bodyPr wrap="square" anchor="ctr" lIns="0" rIns="0" tIns="0" bIns="0">
+            <a:spAutoFit/>
+          </a:bodyPr>
+          <a:lstStyle/>
+          <a:p>
+            <a:pPr algn="ctr">
+              <a:lnSpc>
+                <a:spcPct val="100000"/>
+              </a:lnSpc>
+              <a:spcAft>
+                <a:spcPts val="0"/>
+              </a:spcAft>
+            </a:pPr>
+            <a:r>
+              <a:rPr sz="1300" b="0" i="0">
+                <a:solidFill>
+                  <a:srgbClr val="222A33"/>
+                </a:solidFill>
+                <a:latin typeface="Noto Sans CJK SC"/>
+                <a:ea typeface="Noto Sans CJK SC"/>
+              </a:rPr>
+              <a:t>288</a:t>
+            </a:r>
+          </a:p>
+        </p:txBody>
+      </p:sp>
+      <p:sp>
+        <p:nvSpPr>
+          <p:cNvPr id="57" name="Rectangle 56"/>
+          <p:cNvSpPr/>
+          <p:nvPr/>
+        </p:nvSpPr>
+        <p:spPr>
+          <a:xfrm>
+            <a:off x="566928" y="4645152"/>
+            <a:ext cx="3017520" cy="512064"/>
           </a:xfrm>
           <a:prstGeom prst="rect">
             <a:avLst/>
@@ -18830,14 +19186,14 @@
       </p:sp>
       <p:sp>
         <p:nvSpPr>
-          <p:cNvPr id="50" name="TextBox 49"/>
+          <p:cNvPr id="58" name="TextBox 57"/>
           <p:cNvSpPr txBox="1"/>
           <p:nvPr/>
         </p:nvSpPr>
         <p:spPr>
           <a:xfrm>
-            <a:off x="704088" y="4526280"/>
-            <a:ext cx="2743200" cy="566928"/>
+            <a:off x="704088" y="4645152"/>
+            <a:ext cx="2743200" cy="512064"/>
           </a:xfrm>
           <a:prstGeom prst="rect">
             <a:avLst/>
@@ -18859,7 +19215,7 @@
               </a:spcAft>
             </a:pPr>
             <a:r>
-              <a:rPr sz="1350" b="1" i="0">
+              <a:rPr sz="1300" b="1" i="0">
                 <a:solidFill>
                   <a:srgbClr val="112A46"/>
                 </a:solidFill>
@@ -18873,14 +19229,14 @@
       </p:sp>
       <p:sp>
         <p:nvSpPr>
-          <p:cNvPr id="51" name="Rectangle 50"/>
+          <p:cNvPr id="59" name="Rectangle 58"/>
           <p:cNvSpPr/>
           <p:nvPr/>
         </p:nvSpPr>
         <p:spPr>
           <a:xfrm>
-            <a:off x="3584448" y="4526280"/>
-            <a:ext cx="2651760" cy="566928"/>
+            <a:off x="3584448" y="4645152"/>
+            <a:ext cx="2651760" cy="512064"/>
           </a:xfrm>
           <a:prstGeom prst="rect">
             <a:avLst/>
@@ -18919,14 +19275,14 @@
       </p:sp>
       <p:sp>
         <p:nvSpPr>
-          <p:cNvPr id="52" name="TextBox 51"/>
+          <p:cNvPr id="60" name="TextBox 59"/>
           <p:cNvSpPr txBox="1"/>
           <p:nvPr/>
         </p:nvSpPr>
         <p:spPr>
           <a:xfrm>
-            <a:off x="3721608" y="4526280"/>
-            <a:ext cx="2377440" cy="566928"/>
+            <a:off x="3721608" y="4645152"/>
+            <a:ext cx="2377440" cy="512064"/>
           </a:xfrm>
           <a:prstGeom prst="rect">
             <a:avLst/>
@@ -18948,7 +19304,7 @@
               </a:spcAft>
             </a:pPr>
             <a:r>
-              <a:rPr sz="1350" b="1" i="0">
+              <a:rPr sz="1300" b="1" i="0">
                 <a:solidFill>
                   <a:srgbClr val="112A46"/>
                 </a:solidFill>
@@ -18962,14 +19318,14 @@
       </p:sp>
       <p:sp>
         <p:nvSpPr>
-          <p:cNvPr id="53" name="Rectangle 52"/>
+          <p:cNvPr id="61" name="Rectangle 60"/>
           <p:cNvSpPr/>
           <p:nvPr/>
         </p:nvSpPr>
         <p:spPr>
           <a:xfrm>
-            <a:off x="6236208" y="4526280"/>
-            <a:ext cx="2651760" cy="566928"/>
+            <a:off x="6236208" y="4645152"/>
+            <a:ext cx="2651760" cy="512064"/>
           </a:xfrm>
           <a:prstGeom prst="rect">
             <a:avLst/>
@@ -19008,14 +19364,14 @@
       </p:sp>
       <p:sp>
         <p:nvSpPr>
-          <p:cNvPr id="54" name="TextBox 53"/>
+          <p:cNvPr id="62" name="TextBox 61"/>
           <p:cNvSpPr txBox="1"/>
           <p:nvPr/>
         </p:nvSpPr>
         <p:spPr>
           <a:xfrm>
-            <a:off x="6373368" y="4526280"/>
-            <a:ext cx="2377440" cy="566928"/>
+            <a:off x="6373368" y="4645152"/>
+            <a:ext cx="2377440" cy="512064"/>
           </a:xfrm>
           <a:prstGeom prst="rect">
             <a:avLst/>
@@ -19037,7 +19393,7 @@
               </a:spcAft>
             </a:pPr>
             <a:r>
-              <a:rPr sz="1350" b="1" i="0">
+              <a:rPr sz="1300" b="1" i="0">
                 <a:solidFill>
                   <a:srgbClr val="112A46"/>
                 </a:solidFill>
@@ -19051,14 +19407,14 @@
       </p:sp>
       <p:sp>
         <p:nvSpPr>
-          <p:cNvPr id="55" name="Rectangle 54"/>
+          <p:cNvPr id="63" name="Rectangle 62"/>
           <p:cNvSpPr/>
           <p:nvPr/>
         </p:nvSpPr>
         <p:spPr>
           <a:xfrm>
-            <a:off x="8887968" y="4526280"/>
-            <a:ext cx="2724912" cy="566928"/>
+            <a:off x="8887968" y="4645152"/>
+            <a:ext cx="2724912" cy="512064"/>
           </a:xfrm>
           <a:prstGeom prst="rect">
             <a:avLst/>
@@ -19097,14 +19453,14 @@
       </p:sp>
       <p:sp>
         <p:nvSpPr>
-          <p:cNvPr id="56" name="TextBox 55"/>
+          <p:cNvPr id="64" name="TextBox 63"/>
           <p:cNvSpPr txBox="1"/>
           <p:nvPr/>
         </p:nvSpPr>
         <p:spPr>
           <a:xfrm>
-            <a:off x="9025128" y="4526280"/>
-            <a:ext cx="2450592" cy="566928"/>
+            <a:off x="9025128" y="4645152"/>
+            <a:ext cx="2450592" cy="512064"/>
           </a:xfrm>
           <a:prstGeom prst="rect">
             <a:avLst/>
@@ -19126,7 +19482,7 @@
               </a:spcAft>
             </a:pPr>
             <a:r>
-              <a:rPr sz="1350" b="1" i="0">
+              <a:rPr sz="1300" b="1" i="0">
                 <a:solidFill>
                   <a:srgbClr val="112A46"/>
                 </a:solidFill>
@@ -19140,13 +19496,13 @@
       </p:sp>
       <p:sp>
         <p:nvSpPr>
-          <p:cNvPr id="57" name="Diamond 56"/>
+          <p:cNvPr id="65" name="Diamond 64"/>
           <p:cNvSpPr/>
           <p:nvPr/>
         </p:nvSpPr>
         <p:spPr>
           <a:xfrm>
-            <a:off x="685800" y="5321808"/>
+            <a:off x="685800" y="5340096"/>
             <a:ext cx="128016" cy="128016"/>
           </a:xfrm>
           <a:prstGeom prst="diamond">
@@ -19184,14 +19540,14 @@
       </p:sp>
       <p:sp>
         <p:nvSpPr>
-          <p:cNvPr id="58" name="TextBox 57"/>
+          <p:cNvPr id="66" name="TextBox 65"/>
           <p:cNvSpPr txBox="1"/>
           <p:nvPr/>
         </p:nvSpPr>
         <p:spPr>
           <a:xfrm>
-            <a:off x="960120" y="5239512"/>
-            <a:ext cx="10698480" cy="384048"/>
+            <a:off x="960120" y="5266944"/>
+            <a:ext cx="10698480" cy="365760"/>
           </a:xfrm>
           <a:prstGeom prst="rect">
             <a:avLst/>
@@ -19213,31 +19569,31 @@
               </a:spcAft>
             </a:pPr>
             <a:r>
-              <a:rPr sz="1350" b="1" i="0">
+              <a:rPr sz="1250" b="1" i="0">
                 <a:solidFill>
                   <a:srgbClr val="112A46"/>
                 </a:solidFill>
                 <a:latin typeface="Noto Sans CJK SC"/>
                 <a:ea typeface="Noto Sans CJK SC"/>
               </a:rPr>
-              <a:t>成本结构：</a:t>
-            </a:r>
-            <a:r>
-              <a:rPr sz="1300" b="0" i="0">
+              <a:t>单量口径：</a:t>
+            </a:r>
+            <a:r>
+              <a:rPr sz="1200" b="0" i="0">
                 <a:solidFill>
                   <a:srgbClr val="5A6470"/>
                 </a:solidFill>
                 <a:latin typeface="Noto Sans CJK SC"/>
                 <a:ea typeface="Noto Sans CJK SC"/>
               </a:rPr>
-              <a:t>广告 40% + 货品 30% + 团队运营 8%，经营利润率约 22%；扣除支付手续费、物流保险等杂费后净利率 15%~20%</a:t>
-            </a:r>
-          </a:p>
-        </p:txBody>
-      </p:sp>
-      <p:sp>
-        <p:nvSpPr>
-          <p:cNvPr id="59" name="Diamond 58"/>
+              <a:t>第一年月均约 30 单即达标——对专业投放团队，这是保守的起步目标，可拆到每条广告线复核</a:t>
+            </a:r>
+          </a:p>
+        </p:txBody>
+      </p:sp>
+      <p:sp>
+        <p:nvSpPr>
+          <p:cNvPr id="67" name="Diamond 66"/>
           <p:cNvSpPr/>
           <p:nvPr/>
         </p:nvSpPr>
@@ -19281,14 +19637,14 @@
       </p:sp>
       <p:sp>
         <p:nvSpPr>
-          <p:cNvPr id="60" name="TextBox 59"/>
+          <p:cNvPr id="68" name="TextBox 67"/>
           <p:cNvSpPr txBox="1"/>
           <p:nvPr/>
         </p:nvSpPr>
         <p:spPr>
           <a:xfrm>
-            <a:off x="960120" y="5623560"/>
-            <a:ext cx="10698480" cy="384048"/>
+            <a:off x="960120" y="5632704"/>
+            <a:ext cx="10698480" cy="365760"/>
           </a:xfrm>
           <a:prstGeom prst="rect">
             <a:avLst/>
@@ -19310,37 +19666,37 @@
               </a:spcAft>
             </a:pPr>
             <a:r>
-              <a:rPr sz="1350" b="1" i="0">
+              <a:rPr sz="1250" b="1" i="0">
                 <a:solidFill>
                   <a:srgbClr val="112A46"/>
                 </a:solidFill>
                 <a:latin typeface="Noto Sans CJK SC"/>
                 <a:ea typeface="Noto Sans CJK SC"/>
               </a:rPr>
-              <a:t>零库存模型：</a:t>
-            </a:r>
-            <a:r>
-              <a:rPr sz="1300" b="0" i="0">
+              <a:t>成本结构：</a:t>
+            </a:r>
+            <a:r>
+              <a:rPr sz="1200" b="0" i="0">
                 <a:solidFill>
                   <a:srgbClr val="5A6470"/>
                 </a:solidFill>
                 <a:latin typeface="Noto Sans CJK SC"/>
                 <a:ea typeface="Noto Sans CJK SC"/>
               </a:rPr>
-              <a:t>一件一做，货品成本随订单发生，160 万主要投向流量与团队，资金效率高</a:t>
-            </a:r>
-          </a:p>
-        </p:txBody>
-      </p:sp>
-      <p:sp>
-        <p:nvSpPr>
-          <p:cNvPr id="61" name="Diamond 60"/>
+              <a:t>广告 40% + 货品 30% + 团队运营 8%，经营利润率约 22%；扣除支付手续费、物流保险等杂费后净利率 15%~20%</a:t>
+            </a:r>
+          </a:p>
+        </p:txBody>
+      </p:sp>
+      <p:sp>
+        <p:nvSpPr>
+          <p:cNvPr id="69" name="Diamond 68"/>
           <p:cNvSpPr/>
           <p:nvPr/>
         </p:nvSpPr>
         <p:spPr>
           <a:xfrm>
-            <a:off x="685800" y="6089904"/>
+            <a:off x="685800" y="6071616"/>
             <a:ext cx="128016" cy="128016"/>
           </a:xfrm>
           <a:prstGeom prst="diamond">
@@ -19378,14 +19734,14 @@
       </p:sp>
       <p:sp>
         <p:nvSpPr>
-          <p:cNvPr id="62" name="TextBox 61"/>
+          <p:cNvPr id="70" name="TextBox 69"/>
           <p:cNvSpPr txBox="1"/>
           <p:nvPr/>
         </p:nvSpPr>
         <p:spPr>
           <a:xfrm>
-            <a:off x="960120" y="6007608"/>
-            <a:ext cx="10698480" cy="384048"/>
+            <a:off x="960120" y="5998464"/>
+            <a:ext cx="10698480" cy="365760"/>
           </a:xfrm>
           <a:prstGeom prst="rect">
             <a:avLst/>
@@ -19407,24 +19763,24 @@
               </a:spcAft>
             </a:pPr>
             <a:r>
-              <a:rPr sz="1350" b="1" i="0">
+              <a:rPr sz="1250" b="1" i="0">
                 <a:solidFill>
                   <a:srgbClr val="112A46"/>
                 </a:solidFill>
                 <a:latin typeface="Noto Sans CJK SC"/>
                 <a:ea typeface="Noto Sans CJK SC"/>
               </a:rPr>
-              <a:t>长期愿景：</a:t>
-            </a:r>
-            <a:r>
-              <a:rPr sz="1300" b="0" i="0">
+              <a:t>零库存模型：</a:t>
+            </a:r>
+            <a:r>
+              <a:rPr sz="1200" b="0" i="0">
                 <a:solidFill>
                   <a:srgbClr val="5A6470"/>
                 </a:solidFill>
                 <a:latin typeface="Noto Sans CJK SC"/>
                 <a:ea typeface="Noto Sans CJK SC"/>
               </a:rPr>
-              <a:t>利润来自设计与定制服务溢价；跑通单站模型后复制放大，3~5 年冲击年营收 5,000 万美金量级</a:t>
+              <a:t>一件一做，货品成本随订单发生，160 万主要投向流量与团队，资金效率高</a:t>
             </a:r>
           </a:p>
         </p:txBody>

</xml_diff>

<commit_message>
Add one-line credibility intros for core team members on team slide and speech script
Co-authored-by: devlee <devlee@outlook.com>
</commit_message>
<xml_diff>
--- a/ppt/克拉先生_裂变项目总经理竞选PPT.pptx
+++ b/ppt/克拉先生_裂变项目总经理竞选PPT.pptx
@@ -3870,8 +3870,8 @@
         </p:nvSpPr>
         <p:spPr>
           <a:xfrm>
-            <a:off x="1005840" y="1938528"/>
-            <a:ext cx="4754880" cy="457200"/>
+            <a:off x="1005840" y="1901952"/>
+            <a:ext cx="4754880" cy="411480"/>
           </a:xfrm>
           <a:prstGeom prst="rect">
             <a:avLst/>
@@ -3893,7 +3893,7 @@
               </a:spcAft>
             </a:pPr>
             <a:r>
-              <a:rPr sz="1700" b="1" i="0">
+              <a:rPr sz="1600" b="1" i="0">
                 <a:solidFill>
                   <a:srgbClr val="112A46"/>
                 </a:solidFill>
@@ -3903,7 +3903,7 @@
               <a:t>总经理 / 流量操盘</a:t>
             </a:r>
             <a:r>
-              <a:rPr sz="1400" b="1" i="0">
+              <a:rPr sz="1350" b="1" i="0">
                 <a:solidFill>
                   <a:srgbClr val="C9A24B"/>
                 </a:solidFill>
@@ -3923,8 +3923,8 @@
         </p:nvSpPr>
         <p:spPr>
           <a:xfrm>
-            <a:off x="1005840" y="2514600"/>
-            <a:ext cx="4754880" cy="960120"/>
+            <a:off x="1005840" y="2359152"/>
+            <a:ext cx="4709160" cy="777240"/>
           </a:xfrm>
           <a:prstGeom prst="rect">
             <a:avLst/>
@@ -3939,28 +3939,71 @@
           <a:p>
             <a:pPr algn="l">
               <a:lnSpc>
-                <a:spcPct val="120000"/>
+                <a:spcPct val="115000"/>
               </a:lnSpc>
               <a:spcAft>
                 <a:spcPts val="600"/>
               </a:spcAft>
             </a:pPr>
             <a:r>
-              <a:rPr sz="1300" b="0" i="0">
+              <a:rPr sz="1150" b="0" i="0">
+                <a:solidFill>
+                  <a:srgbClr val="222A33"/>
+                </a:solidFill>
+                <a:latin typeface="Noto Sans CJK SC"/>
+                <a:ea typeface="Noto Sans CJK SC"/>
+              </a:rPr>
+              <a:t>六年打满整个业务链：从客服到投手到项目负责人，累计操盘 1,000 万美金投放，破站点 GMV 纪录。</a:t>
+            </a:r>
+          </a:p>
+        </p:txBody>
+      </p:sp>
+      <p:sp>
+        <p:nvSpPr>
+          <p:cNvPr id="13" name="TextBox 12"/>
+          <p:cNvSpPr txBox="1"/>
+          <p:nvPr/>
+        </p:nvSpPr>
+        <p:spPr>
+          <a:xfrm>
+            <a:off x="1005840" y="3200400"/>
+            <a:ext cx="4709160" cy="365760"/>
+          </a:xfrm>
+          <a:prstGeom prst="rect">
+            <a:avLst/>
+          </a:prstGeom>
+          <a:noFill/>
+        </p:spPr>
+        <p:txBody>
+          <a:bodyPr wrap="square" anchor="t" lIns="0" rIns="0" tIns="0" bIns="0">
+            <a:spAutoFit/>
+          </a:bodyPr>
+          <a:lstStyle/>
+          <a:p>
+            <a:pPr algn="l">
+              <a:lnSpc>
+                <a:spcPct val="100000"/>
+              </a:lnSpc>
+              <a:spcAft>
+                <a:spcPts val="0"/>
+              </a:spcAft>
+            </a:pPr>
+            <a:r>
+              <a:rPr sz="1050" b="0" i="0">
                 <a:solidFill>
                   <a:srgbClr val="5A6470"/>
                 </a:solidFill>
                 <a:latin typeface="Noto Sans CJK SC"/>
                 <a:ea typeface="Noto Sans CJK SC"/>
               </a:rPr>
-              <a:t>战略与经营 · 投放体系搭建 · 广告账户操盘 · ROI 负责</a:t>
-            </a:r>
-          </a:p>
-        </p:txBody>
-      </p:sp>
-      <p:sp>
-        <p:nvSpPr>
-          <p:cNvPr id="13" name="Rounded Rectangle 12"/>
+              <a:t>战略与经营 · 投放体系 · 广告操盘 · ROI 负责</a:t>
+            </a:r>
+          </a:p>
+        </p:txBody>
+      </p:sp>
+      <p:sp>
+        <p:nvSpPr>
+          <p:cNvPr id="14" name="Rounded Rectangle 13"/>
           <p:cNvSpPr/>
           <p:nvPr/>
         </p:nvSpPr>
@@ -4008,7 +4051,7 @@
       </p:sp>
       <p:sp>
         <p:nvSpPr>
-          <p:cNvPr id="14" name="Rectangle 13"/>
+          <p:cNvPr id="15" name="Rectangle 14"/>
           <p:cNvSpPr/>
           <p:nvPr/>
         </p:nvSpPr>
@@ -4052,14 +4095,14 @@
       </p:sp>
       <p:sp>
         <p:nvSpPr>
-          <p:cNvPr id="15" name="TextBox 14"/>
-          <p:cNvSpPr txBox="1"/>
-          <p:nvPr/>
-        </p:nvSpPr>
-        <p:spPr>
-          <a:xfrm>
-            <a:off x="6629400" y="1938528"/>
-            <a:ext cx="4754880" cy="457200"/>
+          <p:cNvPr id="16" name="TextBox 15"/>
+          <p:cNvSpPr txBox="1"/>
+          <p:nvPr/>
+        </p:nvSpPr>
+        <p:spPr>
+          <a:xfrm>
+            <a:off x="6629400" y="1901952"/>
+            <a:ext cx="4754880" cy="411480"/>
           </a:xfrm>
           <a:prstGeom prst="rect">
             <a:avLst/>
@@ -4081,7 +4124,7 @@
               </a:spcAft>
             </a:pPr>
             <a:r>
-              <a:rPr sz="1700" b="1" i="0">
+              <a:rPr sz="1600" b="1" i="0">
                 <a:solidFill>
                   <a:srgbClr val="112A46"/>
                 </a:solidFill>
@@ -4091,7 +4134,7 @@
               <a:t>素材创作负责人</a:t>
             </a:r>
             <a:r>
-              <a:rPr sz="1400" b="1" i="0">
+              <a:rPr sz="1350" b="1" i="0">
                 <a:solidFill>
                   <a:srgbClr val="C9A24B"/>
                 </a:solidFill>
@@ -4105,14 +4148,14 @@
       </p:sp>
       <p:sp>
         <p:nvSpPr>
-          <p:cNvPr id="16" name="TextBox 15"/>
-          <p:cNvSpPr txBox="1"/>
-          <p:nvPr/>
-        </p:nvSpPr>
-        <p:spPr>
-          <a:xfrm>
-            <a:off x="6629400" y="2514600"/>
-            <a:ext cx="4754880" cy="960120"/>
+          <p:cNvPr id="17" name="TextBox 16"/>
+          <p:cNvSpPr txBox="1"/>
+          <p:nvPr/>
+        </p:nvSpPr>
+        <p:spPr>
+          <a:xfrm>
+            <a:off x="6629400" y="2359152"/>
+            <a:ext cx="4709160" cy="777240"/>
           </a:xfrm>
           <a:prstGeom prst="rect">
             <a:avLst/>
@@ -4127,14 +4170,57 @@
           <a:p>
             <a:pPr algn="l">
               <a:lnSpc>
-                <a:spcPct val="120000"/>
+                <a:spcPct val="115000"/>
               </a:lnSpc>
               <a:spcAft>
                 <a:spcPts val="600"/>
               </a:spcAft>
             </a:pPr>
             <a:r>
-              <a:rPr sz="1300" b="0" i="0">
+              <a:rPr sz="1150" b="0" i="0">
+                <a:solidFill>
+                  <a:srgbClr val="222A33"/>
+                </a:solidFill>
+                <a:latin typeface="Noto Sans CJK SC"/>
+                <a:ea typeface="Noto Sans CJK SC"/>
+              </a:rPr>
+              <a:t>__ 年跨境素材实战，从 0 搭建 __ 个站点的拍摄剪辑团队，单条爆款素材带来超 __ 万美金 GMV。</a:t>
+            </a:r>
+          </a:p>
+        </p:txBody>
+      </p:sp>
+      <p:sp>
+        <p:nvSpPr>
+          <p:cNvPr id="18" name="TextBox 17"/>
+          <p:cNvSpPr txBox="1"/>
+          <p:nvPr/>
+        </p:nvSpPr>
+        <p:spPr>
+          <a:xfrm>
+            <a:off x="6629400" y="3200400"/>
+            <a:ext cx="4709160" cy="365760"/>
+          </a:xfrm>
+          <a:prstGeom prst="rect">
+            <a:avLst/>
+          </a:prstGeom>
+          <a:noFill/>
+        </p:spPr>
+        <p:txBody>
+          <a:bodyPr wrap="square" anchor="t" lIns="0" rIns="0" tIns="0" bIns="0">
+            <a:spAutoFit/>
+          </a:bodyPr>
+          <a:lstStyle/>
+          <a:p>
+            <a:pPr algn="l">
+              <a:lnSpc>
+                <a:spcPct val="100000"/>
+              </a:lnSpc>
+              <a:spcAft>
+                <a:spcPts val="0"/>
+              </a:spcAft>
+            </a:pPr>
+            <a:r>
+              <a:rPr sz="1050" b="0" i="0">
                 <a:solidFill>
                   <a:srgbClr val="5A6470"/>
                 </a:solidFill>
@@ -4148,7 +4234,7 @@
       </p:sp>
       <p:sp>
         <p:nvSpPr>
-          <p:cNvPr id="17" name="Rounded Rectangle 16"/>
+          <p:cNvPr id="19" name="Rounded Rectangle 18"/>
           <p:cNvSpPr/>
           <p:nvPr/>
         </p:nvSpPr>
@@ -4196,7 +4282,7 @@
       </p:sp>
       <p:sp>
         <p:nvSpPr>
-          <p:cNvPr id="18" name="Rectangle 17"/>
+          <p:cNvPr id="20" name="Rectangle 19"/>
           <p:cNvSpPr/>
           <p:nvPr/>
         </p:nvSpPr>
@@ -4240,14 +4326,14 @@
       </p:sp>
       <p:sp>
         <p:nvSpPr>
-          <p:cNvPr id="19" name="TextBox 18"/>
-          <p:cNvSpPr txBox="1"/>
-          <p:nvPr/>
-        </p:nvSpPr>
-        <p:spPr>
-          <a:xfrm>
-            <a:off x="1005840" y="4041648"/>
-            <a:ext cx="4754880" cy="457200"/>
+          <p:cNvPr id="21" name="TextBox 20"/>
+          <p:cNvSpPr txBox="1"/>
+          <p:nvPr/>
+        </p:nvSpPr>
+        <p:spPr>
+          <a:xfrm>
+            <a:off x="1005840" y="4005072"/>
+            <a:ext cx="4754880" cy="411480"/>
           </a:xfrm>
           <a:prstGeom prst="rect">
             <a:avLst/>
@@ -4269,7 +4355,7 @@
               </a:spcAft>
             </a:pPr>
             <a:r>
-              <a:rPr sz="1700" b="1" i="0">
+              <a:rPr sz="1600" b="1" i="0">
                 <a:solidFill>
                   <a:srgbClr val="112A46"/>
                 </a:solidFill>
@@ -4279,7 +4365,7 @@
               <a:t>设计与供应链负责人</a:t>
             </a:r>
             <a:r>
-              <a:rPr sz="1400" b="1" i="0">
+              <a:rPr sz="1350" b="1" i="0">
                 <a:solidFill>
                   <a:srgbClr val="C9A24B"/>
                 </a:solidFill>
@@ -4293,14 +4379,14 @@
       </p:sp>
       <p:sp>
         <p:nvSpPr>
-          <p:cNvPr id="20" name="TextBox 19"/>
-          <p:cNvSpPr txBox="1"/>
-          <p:nvPr/>
-        </p:nvSpPr>
-        <p:spPr>
-          <a:xfrm>
-            <a:off x="1005840" y="4617720"/>
-            <a:ext cx="4754880" cy="960120"/>
+          <p:cNvPr id="22" name="TextBox 21"/>
+          <p:cNvSpPr txBox="1"/>
+          <p:nvPr/>
+        </p:nvSpPr>
+        <p:spPr>
+          <a:xfrm>
+            <a:off x="1005840" y="4462272"/>
+            <a:ext cx="4709160" cy="777240"/>
           </a:xfrm>
           <a:prstGeom prst="rect">
             <a:avLst/>
@@ -4315,28 +4401,71 @@
           <a:p>
             <a:pPr algn="l">
               <a:lnSpc>
-                <a:spcPct val="120000"/>
+                <a:spcPct val="115000"/>
               </a:lnSpc>
               <a:spcAft>
                 <a:spcPts val="600"/>
               </a:spcAft>
             </a:pPr>
             <a:r>
-              <a:rPr sz="1300" b="0" i="0">
+              <a:rPr sz="1150" b="0" i="0">
+                <a:solidFill>
+                  <a:srgbClr val="222A33"/>
+                </a:solidFill>
+                <a:latin typeface="Noto Sans CJK SC"/>
+                <a:ea typeface="Noto Sans CJK SC"/>
+              </a:rPr>
+              <a:t>深耕珠宝供应链 __ 年，直连印度源头钻石商与同源体系金工工坊，管理过年出货 __ 件的定制产线。</a:t>
+            </a:r>
+          </a:p>
+        </p:txBody>
+      </p:sp>
+      <p:sp>
+        <p:nvSpPr>
+          <p:cNvPr id="23" name="TextBox 22"/>
+          <p:cNvSpPr txBox="1"/>
+          <p:nvPr/>
+        </p:nvSpPr>
+        <p:spPr>
+          <a:xfrm>
+            <a:off x="1005840" y="5303520"/>
+            <a:ext cx="4709160" cy="365760"/>
+          </a:xfrm>
+          <a:prstGeom prst="rect">
+            <a:avLst/>
+          </a:prstGeom>
+          <a:noFill/>
+        </p:spPr>
+        <p:txBody>
+          <a:bodyPr wrap="square" anchor="t" lIns="0" rIns="0" tIns="0" bIns="0">
+            <a:spAutoFit/>
+          </a:bodyPr>
+          <a:lstStyle/>
+          <a:p>
+            <a:pPr algn="l">
+              <a:lnSpc>
+                <a:spcPct val="100000"/>
+              </a:lnSpc>
+              <a:spcAft>
+                <a:spcPts val="0"/>
+              </a:spcAft>
+            </a:pPr>
+            <a:r>
+              <a:rPr sz="1050" b="0" i="0">
                 <a:solidFill>
                   <a:srgbClr val="5A6470"/>
                 </a:solidFill>
                 <a:latin typeface="Noto Sans CJK SC"/>
                 <a:ea typeface="Noto Sans CJK SC"/>
               </a:rPr>
-              <a:t>AI 设计模型 · 印度源头选钻 · 金工大师排单与品控</a:t>
-            </a:r>
-          </a:p>
-        </p:txBody>
-      </p:sp>
-      <p:sp>
-        <p:nvSpPr>
-          <p:cNvPr id="21" name="Rounded Rectangle 20"/>
+              <a:t>AI 设计模型 · 印度源头选钻 · 金工排单与品控</a:t>
+            </a:r>
+          </a:p>
+        </p:txBody>
+      </p:sp>
+      <p:sp>
+        <p:nvSpPr>
+          <p:cNvPr id="24" name="Rounded Rectangle 23"/>
           <p:cNvSpPr/>
           <p:nvPr/>
         </p:nvSpPr>
@@ -4384,7 +4513,7 @@
       </p:sp>
       <p:sp>
         <p:nvSpPr>
-          <p:cNvPr id="22" name="Rectangle 21"/>
+          <p:cNvPr id="25" name="Rectangle 24"/>
           <p:cNvSpPr/>
           <p:nvPr/>
         </p:nvSpPr>
@@ -4428,14 +4557,14 @@
       </p:sp>
       <p:sp>
         <p:nvSpPr>
-          <p:cNvPr id="23" name="TextBox 22"/>
-          <p:cNvSpPr txBox="1"/>
-          <p:nvPr/>
-        </p:nvSpPr>
-        <p:spPr>
-          <a:xfrm>
-            <a:off x="6629400" y="4041648"/>
-            <a:ext cx="4754880" cy="457200"/>
+          <p:cNvPr id="26" name="TextBox 25"/>
+          <p:cNvSpPr txBox="1"/>
+          <p:nvPr/>
+        </p:nvSpPr>
+        <p:spPr>
+          <a:xfrm>
+            <a:off x="6629400" y="4005072"/>
+            <a:ext cx="4754880" cy="411480"/>
           </a:xfrm>
           <a:prstGeom prst="rect">
             <a:avLst/>
@@ -4457,7 +4586,7 @@
               </a:spcAft>
             </a:pPr>
             <a:r>
-              <a:rPr sz="1700" b="1" i="0">
+              <a:rPr sz="1600" b="1" i="0">
                 <a:solidFill>
                   <a:srgbClr val="112A46"/>
                 </a:solidFill>
@@ -4467,7 +4596,7 @@
               <a:t>定制顾问 / 客服负责人</a:t>
             </a:r>
             <a:r>
-              <a:rPr sz="1400" b="1" i="0">
+              <a:rPr sz="1350" b="1" i="0">
                 <a:solidFill>
                   <a:srgbClr val="C9A24B"/>
                 </a:solidFill>
@@ -4481,14 +4610,14 @@
       </p:sp>
       <p:sp>
         <p:nvSpPr>
-          <p:cNvPr id="24" name="TextBox 23"/>
-          <p:cNvSpPr txBox="1"/>
-          <p:nvPr/>
-        </p:nvSpPr>
-        <p:spPr>
-          <a:xfrm>
-            <a:off x="6629400" y="4617720"/>
-            <a:ext cx="4754880" cy="960120"/>
+          <p:cNvPr id="27" name="TextBox 26"/>
+          <p:cNvSpPr txBox="1"/>
+          <p:nvPr/>
+        </p:nvSpPr>
+        <p:spPr>
+          <a:xfrm>
+            <a:off x="6629400" y="4462272"/>
+            <a:ext cx="4709160" cy="777240"/>
           </a:xfrm>
           <a:prstGeom prst="rect">
             <a:avLst/>
@@ -4503,14 +4632,57 @@
           <a:p>
             <a:pPr algn="l">
               <a:lnSpc>
-                <a:spcPct val="120000"/>
+                <a:spcPct val="115000"/>
               </a:lnSpc>
               <a:spcAft>
                 <a:spcPts val="600"/>
               </a:spcAft>
             </a:pPr>
             <a:r>
-              <a:rPr sz="1300" b="0" i="0">
+              <a:rPr sz="1150" b="0" i="0">
+                <a:solidFill>
+                  <a:srgbClr val="222A33"/>
+                </a:solidFill>
+                <a:latin typeface="Noto Sans CJK SC"/>
+                <a:ea typeface="Noto Sans CJK SC"/>
+              </a:rPr>
+              <a:t>一线客服成长起来的转化专家，__ 年高客单询单经验，历史询单转化率 __%、客诉率低于 __%。</a:t>
+            </a:r>
+          </a:p>
+        </p:txBody>
+      </p:sp>
+      <p:sp>
+        <p:nvSpPr>
+          <p:cNvPr id="28" name="TextBox 27"/>
+          <p:cNvSpPr txBox="1"/>
+          <p:nvPr/>
+        </p:nvSpPr>
+        <p:spPr>
+          <a:xfrm>
+            <a:off x="6629400" y="5303520"/>
+            <a:ext cx="4709160" cy="365760"/>
+          </a:xfrm>
+          <a:prstGeom prst="rect">
+            <a:avLst/>
+          </a:prstGeom>
+          <a:noFill/>
+        </p:spPr>
+        <p:txBody>
+          <a:bodyPr wrap="square" anchor="t" lIns="0" rIns="0" tIns="0" bIns="0">
+            <a:spAutoFit/>
+          </a:bodyPr>
+          <a:lstStyle/>
+          <a:p>
+            <a:pPr algn="l">
+              <a:lnSpc>
+                <a:spcPct val="100000"/>
+              </a:lnSpc>
+              <a:spcAft>
+                <a:spcPts val="0"/>
+              </a:spcAft>
+            </a:pPr>
+            <a:r>
+              <a:rPr sz="1050" b="0" i="0">
                 <a:solidFill>
                   <a:srgbClr val="5A6470"/>
                 </a:solidFill>
@@ -4524,7 +4696,7 @@
       </p:sp>
       <p:sp>
         <p:nvSpPr>
-          <p:cNvPr id="25" name="TextBox 24"/>
+          <p:cNvPr id="29" name="TextBox 28"/>
           <p:cNvSpPr txBox="1"/>
           <p:nvPr/>
         </p:nvSpPr>

</xml_diff>

<commit_message>
Reposition: custom work as add-on service not core, AOV $450 with recalculated volumes, filled team intros
Co-authored-by: devlee <devlee@outlook.com>
</commit_message>
<xml_diff>
--- a/ppt/克拉先生_裂变项目总经理竞选PPT.pptx
+++ b/ppt/克拉先生_裂变项目总经理竞选PPT.pptx
@@ -4184,7 +4184,7 @@
                 <a:latin typeface="Noto Sans CJK SC"/>
                 <a:ea typeface="Noto Sans CJK SC"/>
               </a:rPr>
-              <a:t>__ 年跨境素材实战，从 0 搭建 __ 个站点的拍摄剪辑团队，单条爆款素材带来超 __ 万美金 GMV。</a:t>
+              <a:t>5 年跨境素材实战，从 0 搭建 2 个站点的拍摄剪辑团队，单条爆款素材带来超 50 万美金 GMV。</a:t>
             </a:r>
           </a:p>
         </p:txBody>
@@ -4415,7 +4415,7 @@
                 <a:latin typeface="Noto Sans CJK SC"/>
                 <a:ea typeface="Noto Sans CJK SC"/>
               </a:rPr>
-              <a:t>深耕珠宝供应链 __ 年，直连印度源头钻石商与同源体系金工工坊，管理过年出货 __ 件的定制产线。</a:t>
+              <a:t>深耕珠宝供应链 8 年，直连印度源头钻石商与同源体系金工工坊，管理过年出货 3 万件的珠宝产线。</a:t>
             </a:r>
           </a:p>
         </p:txBody>
@@ -4593,7 +4593,7 @@
                 <a:latin typeface="Noto Sans CJK SC"/>
                 <a:ea typeface="Noto Sans CJK SC"/>
               </a:rPr>
-              <a:t>定制顾问 / 客服负责人</a:t>
+              <a:t>销售顾问 / 客服负责人</a:t>
             </a:r>
             <a:r>
               <a:rPr sz="1350" b="1" i="0">
@@ -4646,7 +4646,7 @@
                 <a:latin typeface="Noto Sans CJK SC"/>
                 <a:ea typeface="Noto Sans CJK SC"/>
               </a:rPr>
-              <a:t>一线客服成长起来的转化专家，__ 年高客单询单经验，历史询单转化率 __%、客诉率低于 __%。</a:t>
+              <a:t>一线客服成长起来的转化专家，6 年高客单询单经验，历史询单转化率 30%、客诉率低于 1%。</a:t>
             </a:r>
           </a:p>
         </p:txBody>
@@ -4689,7 +4689,7 @@
                 <a:latin typeface="Noto Sans CJK SC"/>
                 <a:ea typeface="Noto Sans CJK SC"/>
               </a:rPr>
-              <a:t>1v1 定制服务 · 询单转化 · 售后与复购运营</a:t>
+              <a:t>1v1 顾问服务 · 询单转化 · 售后与复购运营</a:t>
             </a:r>
           </a:p>
         </p:txBody>
@@ -6676,7 +6676,7 @@
                 <a:latin typeface="Noto Sans CJK SC"/>
                 <a:ea typeface="Noto Sans CJK SC"/>
               </a:rPr>
-              <a:t>· 利润锚定设计与服务溢价，15%~20%</a:t>
+              <a:t>· 利润锚定品牌与设计溢价，15%~20%</a:t>
             </a:r>
           </a:p>
         </p:txBody>
@@ -10376,7 +10376,7 @@
                 <a:latin typeface="Noto Sans CJK SC"/>
                 <a:ea typeface="Noto Sans CJK SC"/>
               </a:rPr>
-              <a:t>在美国婚戒市场，用培育钻 + 定制服务切一块确定性增长的蛋糕</a:t>
+              <a:t>在美国婚戒市场，用培育钻婚戒成品 + 顾问式服务切一块确定性增长的蛋糕</a:t>
             </a:r>
           </a:p>
         </p:txBody>
@@ -10883,7 +10883,7 @@
                 <a:latin typeface="Noto Sans CJK SC"/>
                 <a:ea typeface="Noto Sans CJK SC"/>
               </a:rPr>
-              <a:t>高客单高毛利：</a:t>
+              <a:t>情感品类高毛利：</a:t>
             </a:r>
             <a:r>
               <a:rPr sz="1350" b="0" i="0">
@@ -10893,7 +10893,7 @@
                 <a:latin typeface="Noto Sans CJK SC"/>
                 <a:ea typeface="Noto Sans CJK SC"/>
               </a:rPr>
-              <a:t>婚戒是强情感、强定制品类，服务与设计溢价空间大</a:t>
+              <a:t>婚戒是强情感品类，品牌与设计的溢价空间大</a:t>
             </a:r>
           </a:p>
         </p:txBody>
@@ -11045,7 +11045,7 @@
                 <a:latin typeface="Noto Sans CJK SC"/>
                 <a:ea typeface="Noto Sans CJK SC"/>
               </a:rPr>
-              <a:t>培育钻婚戒 / 订婚戒（IGI·GIA 证书裸钻 + 18K 金/铂金戒托）</a:t>
+              <a:t>培育钻婚戒成品款式库（IGI·GIA 证书培育钻 + K 金戒托），客单价约 $450</a:t>
             </a:r>
           </a:p>
         </p:txBody>
@@ -11108,7 +11108,7 @@
                 <a:latin typeface="Noto Sans CJK SC"/>
                 <a:ea typeface="Noto Sans CJK SC"/>
               </a:rPr>
-              <a:t>1v1 定制顾问全程陪跑：选钻 → AI 出图 → 大师手作 → 保险直邮</a:t>
+              <a:t>1v1 顾问服务：选款推荐 → 效果确认 → 大师手作 → 保险直邮</a:t>
             </a:r>
           </a:p>
         </p:txBody>
@@ -11151,7 +11151,7 @@
                 <a:latin typeface="Noto Sans CJK SC"/>
                 <a:ea typeface="Noto Sans CJK SC"/>
               </a:rPr>
-              <a:t>交付模式  </a:t>
+              <a:t>增值服务  </a:t>
             </a:r>
           </a:p>
           <a:p>
@@ -11171,7 +11171,7 @@
                 <a:latin typeface="Noto Sans CJK SC"/>
                 <a:ea typeface="Noto Sans CJK SC"/>
               </a:rPr>
-              <a:t>一件一做、按单生产，支持刻字、改圈、终身保养</a:t>
+              <a:t>个性化定制、免费刻字、改圈、终身保养（可选加购）</a:t>
             </a:r>
           </a:p>
         </p:txBody>
@@ -11234,7 +11234,7 @@
                 <a:latin typeface="Noto Sans CJK SC"/>
                 <a:ea typeface="Noto Sans CJK SC"/>
               </a:rPr>
-              <a:t>品牌独立站 DTC 直达消费者，不依赖平台与门店</a:t>
+              <a:t>品牌独立站 DTC 直达消费者，一件一做、按单生产，不依赖平台与门店</a:t>
             </a:r>
           </a:p>
         </p:txBody>
@@ -12121,7 +12121,7 @@
                 <a:latin typeface="Noto Sans CJK SC"/>
                 <a:ea typeface="Noto Sans CJK SC"/>
               </a:rPr>
-              <a:t>定制服务</a:t>
+              <a:t>增值服务</a:t>
             </a:r>
           </a:p>
         </p:txBody>
@@ -12326,7 +12326,7 @@
                 <a:latin typeface="Noto Sans CJK SC"/>
                 <a:ea typeface="Noto Sans CJK SC"/>
               </a:rPr>
-              <a:t>克拉先生 Mr. Karat：一件一做的美国培育钻婚戒定制品牌</a:t>
+              <a:t>克拉先生 Mr. Karat：一件一做的美国培育钻婚戒品牌</a:t>
             </a:r>
           </a:p>
         </p:txBody>
@@ -12995,7 +12995,7 @@
                 <a:latin typeface="Noto Sans CJK SC"/>
                 <a:ea typeface="Noto Sans CJK SC"/>
               </a:rPr>
-              <a:t>定制服务承接</a:t>
+              <a:t>顾问式服务</a:t>
             </a:r>
           </a:p>
         </p:txBody>
@@ -13038,7 +13038,7 @@
                 <a:latin typeface="Noto Sans CJK SC"/>
                 <a:ea typeface="Noto Sans CJK SC"/>
               </a:rPr>
-              <a:t>1v1 顾问承接高客单决策，转化与复购的信任基石</a:t>
+              <a:t>1v1 顾问承接询单，定制/刻字等增值服务提客单，转化与复购的基石</a:t>
             </a:r>
           </a:p>
         </p:txBody>
@@ -16693,7 +16693,7 @@
                 <a:latin typeface="Noto Sans CJK SC"/>
                 <a:ea typeface="Noto Sans CJK SC"/>
               </a:rPr>
-              <a:t>1v1 定制顾问：选钻教学 → 3D 效果图 → 分期支付</a:t>
+              <a:t>1v1 顾问：选款推荐 → 效果图确认 → 分期支付</a:t>
             </a:r>
           </a:p>
         </p:txBody>
@@ -17083,7 +17083,7 @@
                 <a:latin typeface="Noto Sans CJK SC"/>
                 <a:ea typeface="Noto Sans CJK SC"/>
               </a:rPr>
-              <a:t>总投入 160 万（3 年储备） · 净利率 15%~20% · 客单价按 $2,000（约 1.4 万元）测算，示例口径可复核</a:t>
+              <a:t>总投入 160 万（3 年储备） · 净利率 15%~20% · 客单价按 $450（约 3,200 元）测算，示例口径可复核</a:t>
             </a:r>
           </a:p>
         </p:txBody>
@@ -18059,7 +18059,7 @@
                 <a:latin typeface="Noto Sans CJK SC"/>
                 <a:ea typeface="Noto Sans CJK SC"/>
               </a:rPr>
-              <a:t>约 360 单（月均 30）</a:t>
+              <a:t>约 1,560 单（月均 130）</a:t>
             </a:r>
           </a:p>
         </p:txBody>
@@ -18148,7 +18148,7 @@
                 <a:latin typeface="Noto Sans CJK SC"/>
                 <a:ea typeface="Noto Sans CJK SC"/>
               </a:rPr>
-              <a:t>约 1,070 单（月均 90）</a:t>
+              <a:t>约 4,690 单（月均 390）</a:t>
             </a:r>
           </a:p>
         </p:txBody>
@@ -18237,7 +18237,7 @@
                 <a:latin typeface="Noto Sans CJK SC"/>
                 <a:ea typeface="Noto Sans CJK SC"/>
               </a:rPr>
-              <a:t>约 2,570 单（月均 215）</a:t>
+              <a:t>约 11,250 单（月均 940）</a:t>
             </a:r>
           </a:p>
         </p:txBody>
@@ -19758,7 +19758,7 @@
                 <a:latin typeface="Noto Sans CJK SC"/>
                 <a:ea typeface="Noto Sans CJK SC"/>
               </a:rPr>
-              <a:t>第一年月均约 30 单即达标——对专业投放团队，这是保守的起步目标，可拆到每条广告线复核</a:t>
+              <a:t>第一年月均约 130 单、日均 4~5 单即达标——对专业投放团队，这是保守的起步目标，可拆到每条广告线复核</a:t>
             </a:r>
           </a:p>
         </p:txBody>

</xml_diff>